<commit_message>
changed to here page
</commit_message>
<xml_diff>
--- a/lectures/Week03_UMLAWTSwingGraphics/2_SwingAWTEventsGraphics2D_V4.pptx
+++ b/lectures/Week03_UMLAWTSwingGraphics/2_SwingAWTEventsGraphics2D_V4.pptx
@@ -54,30 +54,30 @@
     <p:sldId id="518" r:id="rId42"/>
     <p:sldId id="519" r:id="rId43"/>
     <p:sldId id="520" r:id="rId44"/>
-    <p:sldId id="521" r:id="rId45"/>
-    <p:sldId id="522" r:id="rId46"/>
-    <p:sldId id="523" r:id="rId47"/>
-    <p:sldId id="524" r:id="rId48"/>
-    <p:sldId id="525" r:id="rId49"/>
-    <p:sldId id="526" r:id="rId50"/>
-    <p:sldId id="527" r:id="rId51"/>
-    <p:sldId id="528" r:id="rId52"/>
-    <p:sldId id="529" r:id="rId53"/>
-    <p:sldId id="530" r:id="rId54"/>
-    <p:sldId id="531" r:id="rId55"/>
-    <p:sldId id="532" r:id="rId56"/>
-    <p:sldId id="533" r:id="rId57"/>
-    <p:sldId id="534" r:id="rId58"/>
-    <p:sldId id="535" r:id="rId59"/>
-    <p:sldId id="536" r:id="rId60"/>
-    <p:sldId id="537" r:id="rId61"/>
-    <p:sldId id="538" r:id="rId62"/>
-    <p:sldId id="539" r:id="rId63"/>
-    <p:sldId id="540" r:id="rId64"/>
-    <p:sldId id="541" r:id="rId65"/>
-    <p:sldId id="542" r:id="rId66"/>
-    <p:sldId id="483" r:id="rId67"/>
-    <p:sldId id="548" r:id="rId68"/>
+    <p:sldId id="548" r:id="rId45"/>
+    <p:sldId id="521" r:id="rId46"/>
+    <p:sldId id="522" r:id="rId47"/>
+    <p:sldId id="523" r:id="rId48"/>
+    <p:sldId id="524" r:id="rId49"/>
+    <p:sldId id="525" r:id="rId50"/>
+    <p:sldId id="526" r:id="rId51"/>
+    <p:sldId id="527" r:id="rId52"/>
+    <p:sldId id="528" r:id="rId53"/>
+    <p:sldId id="529" r:id="rId54"/>
+    <p:sldId id="530" r:id="rId55"/>
+    <p:sldId id="531" r:id="rId56"/>
+    <p:sldId id="532" r:id="rId57"/>
+    <p:sldId id="533" r:id="rId58"/>
+    <p:sldId id="534" r:id="rId59"/>
+    <p:sldId id="535" r:id="rId60"/>
+    <p:sldId id="536" r:id="rId61"/>
+    <p:sldId id="537" r:id="rId62"/>
+    <p:sldId id="538" r:id="rId63"/>
+    <p:sldId id="539" r:id="rId64"/>
+    <p:sldId id="540" r:id="rId65"/>
+    <p:sldId id="541" r:id="rId66"/>
+    <p:sldId id="542" r:id="rId67"/>
+    <p:sldId id="483" r:id="rId68"/>
   </p:sldIdLst>
   <p:sldSz cx="12192000" cy="6858000"/>
   <p:notesSz cx="7010400" cy="9296400"/>
@@ -18872,7 +18872,13 @@
   <p:cSld>
     <p:spTree>
       <p:nvGrpSpPr>
-        <p:cNvPr id="1" name=""/>
+        <p:cNvPr id="1" name="">
+          <a:extLst>
+            <a:ext uri="{FF2B5EF4-FFF2-40B4-BE49-F238E27FC236}">
+              <a16:creationId xmlns:a16="http://schemas.microsoft.com/office/drawing/2014/main" id="{84DA25F2-3AE0-BDCF-0880-EDD5EEF55E54}"/>
+            </a:ext>
+          </a:extLst>
+        </p:cNvPr>
         <p:cNvGrpSpPr/>
         <p:nvPr/>
       </p:nvGrpSpPr>
@@ -18886,269 +18892,36 @@
       </p:grpSpPr>
       <p:sp>
         <p:nvSpPr>
-          <p:cNvPr id="2" name="Title 1"/>
+          <p:cNvPr id="2" name="Title 1">
+            <a:extLst>
+              <a:ext uri="{FF2B5EF4-FFF2-40B4-BE49-F238E27FC236}">
+                <a16:creationId xmlns:a16="http://schemas.microsoft.com/office/drawing/2014/main" id="{6EAE57A2-3A61-C5F8-EEFD-EA2961784338}"/>
+              </a:ext>
+            </a:extLst>
+          </p:cNvPr>
           <p:cNvSpPr>
             <a:spLocks noGrp="1"/>
           </p:cNvSpPr>
           <p:nvPr>
-            <p:ph type="title"/>
+            <p:ph type="ctrTitle"/>
           </p:nvPr>
         </p:nvSpPr>
         <p:spPr/>
         <p:txBody>
-          <a:bodyPr rtlCol="0">
-            <a:normAutofit/>
-          </a:bodyPr>
+          <a:bodyPr/>
           <a:lstStyle/>
           <a:p>
-            <a:pPr>
-              <a:defRPr/>
-            </a:pPr>
             <a:r>
               <a:rPr lang="en-US" dirty="0"/>
-              <a:t>Overwriting paint method (AWT)</a:t>
-            </a:r>
-          </a:p>
-        </p:txBody>
-      </p:sp>
-      <p:sp>
-        <p:nvSpPr>
-          <p:cNvPr id="5123" name="Slide Number Placeholder 3"/>
-          <p:cNvSpPr>
-            <a:spLocks noGrp="1"/>
-          </p:cNvSpPr>
-          <p:nvPr>
-            <p:ph type="sldNum" sz="quarter" idx="4294967295"/>
-          </p:nvPr>
-        </p:nvSpPr>
-        <p:spPr bwMode="auto">
-          <a:noFill/>
-          <a:extLst>
-            <a:ext uri="{909E8E84-426E-40DD-AFC4-6F175D3DCCD1}">
-              <a14:hiddenFill xmlns:a14="http://schemas.microsoft.com/office/drawing/2010/main">
-                <a:solidFill>
-                  <a:srgbClr val="FFFFFF"/>
-                </a:solidFill>
-              </a14:hiddenFill>
-            </a:ext>
-            <a:ext uri="{91240B29-F687-4F45-9708-019B960494DF}">
-              <a14:hiddenLine xmlns:a14="http://schemas.microsoft.com/office/drawing/2010/main" w="9525">
-                <a:solidFill>
-                  <a:srgbClr val="000000"/>
-                </a:solidFill>
-                <a:miter lim="800000"/>
-                <a:headEnd/>
-                <a:tailEnd/>
-              </a14:hiddenLine>
-            </a:ext>
-          </a:extLst>
-        </p:spPr>
-        <p:txBody>
-          <a:bodyPr/>
-          <a:lstStyle>
-            <a:lvl1pPr>
-              <a:spcBef>
-                <a:spcPct val="20000"/>
-              </a:spcBef>
-              <a:buFont typeface="Arial" panose="020B0604020202020204" pitchFamily="34" charset="0"/>
-              <a:buChar char="•"/>
-              <a:defRPr sz="3200">
-                <a:solidFill>
-                  <a:schemeClr val="tx1"/>
-                </a:solidFill>
-                <a:latin typeface="Calibri" panose="020F0502020204030204" pitchFamily="34" charset="0"/>
-              </a:defRPr>
-            </a:lvl1pPr>
-            <a:lvl2pPr marL="742950" indent="-285750">
-              <a:spcBef>
-                <a:spcPct val="20000"/>
-              </a:spcBef>
-              <a:buFont typeface="Arial" panose="020B0604020202020204" pitchFamily="34" charset="0"/>
-              <a:buChar char="–"/>
-              <a:defRPr sz="2800">
-                <a:solidFill>
-                  <a:schemeClr val="tx1"/>
-                </a:solidFill>
-                <a:latin typeface="Calibri" panose="020F0502020204030204" pitchFamily="34" charset="0"/>
-              </a:defRPr>
-            </a:lvl2pPr>
-            <a:lvl3pPr marL="1143000" indent="-228600">
-              <a:spcBef>
-                <a:spcPct val="20000"/>
-              </a:spcBef>
-              <a:buFont typeface="Arial" panose="020B0604020202020204" pitchFamily="34" charset="0"/>
-              <a:buChar char="•"/>
-              <a:defRPr sz="2400">
-                <a:solidFill>
-                  <a:schemeClr val="tx1"/>
-                </a:solidFill>
-                <a:latin typeface="Calibri" panose="020F0502020204030204" pitchFamily="34" charset="0"/>
-              </a:defRPr>
-            </a:lvl3pPr>
-            <a:lvl4pPr marL="1600200" indent="-228600">
-              <a:spcBef>
-                <a:spcPct val="20000"/>
-              </a:spcBef>
-              <a:buFont typeface="Arial" panose="020B0604020202020204" pitchFamily="34" charset="0"/>
-              <a:buChar char="–"/>
-              <a:defRPr sz="2000">
-                <a:solidFill>
-                  <a:schemeClr val="tx1"/>
-                </a:solidFill>
-                <a:latin typeface="Calibri" panose="020F0502020204030204" pitchFamily="34" charset="0"/>
-              </a:defRPr>
-            </a:lvl4pPr>
-            <a:lvl5pPr marL="2057400" indent="-228600">
-              <a:spcBef>
-                <a:spcPct val="20000"/>
-              </a:spcBef>
-              <a:buFont typeface="Arial" panose="020B0604020202020204" pitchFamily="34" charset="0"/>
-              <a:buChar char="»"/>
-              <a:defRPr sz="2000">
-                <a:solidFill>
-                  <a:schemeClr val="tx1"/>
-                </a:solidFill>
-                <a:latin typeface="Calibri" panose="020F0502020204030204" pitchFamily="34" charset="0"/>
-              </a:defRPr>
-            </a:lvl5pPr>
-            <a:lvl6pPr marL="2514600" indent="-228600" eaLnBrk="0" fontAlgn="base" hangingPunct="0">
-              <a:spcBef>
-                <a:spcPct val="20000"/>
-              </a:spcBef>
-              <a:spcAft>
-                <a:spcPct val="0"/>
-              </a:spcAft>
-              <a:buFont typeface="Arial" panose="020B0604020202020204" pitchFamily="34" charset="0"/>
-              <a:buChar char="»"/>
-              <a:defRPr sz="2000">
-                <a:solidFill>
-                  <a:schemeClr val="tx1"/>
-                </a:solidFill>
-                <a:latin typeface="Calibri" panose="020F0502020204030204" pitchFamily="34" charset="0"/>
-              </a:defRPr>
-            </a:lvl6pPr>
-            <a:lvl7pPr marL="2971800" indent="-228600" eaLnBrk="0" fontAlgn="base" hangingPunct="0">
-              <a:spcBef>
-                <a:spcPct val="20000"/>
-              </a:spcBef>
-              <a:spcAft>
-                <a:spcPct val="0"/>
-              </a:spcAft>
-              <a:buFont typeface="Arial" panose="020B0604020202020204" pitchFamily="34" charset="0"/>
-              <a:buChar char="»"/>
-              <a:defRPr sz="2000">
-                <a:solidFill>
-                  <a:schemeClr val="tx1"/>
-                </a:solidFill>
-                <a:latin typeface="Calibri" panose="020F0502020204030204" pitchFamily="34" charset="0"/>
-              </a:defRPr>
-            </a:lvl7pPr>
-            <a:lvl8pPr marL="3429000" indent="-228600" eaLnBrk="0" fontAlgn="base" hangingPunct="0">
-              <a:spcBef>
-                <a:spcPct val="20000"/>
-              </a:spcBef>
-              <a:spcAft>
-                <a:spcPct val="0"/>
-              </a:spcAft>
-              <a:buFont typeface="Arial" panose="020B0604020202020204" pitchFamily="34" charset="0"/>
-              <a:buChar char="»"/>
-              <a:defRPr sz="2000">
-                <a:solidFill>
-                  <a:schemeClr val="tx1"/>
-                </a:solidFill>
-                <a:latin typeface="Calibri" panose="020F0502020204030204" pitchFamily="34" charset="0"/>
-              </a:defRPr>
-            </a:lvl8pPr>
-            <a:lvl9pPr marL="3886200" indent="-228600" eaLnBrk="0" fontAlgn="base" hangingPunct="0">
-              <a:spcBef>
-                <a:spcPct val="20000"/>
-              </a:spcBef>
-              <a:spcAft>
-                <a:spcPct val="0"/>
-              </a:spcAft>
-              <a:buFont typeface="Arial" panose="020B0604020202020204" pitchFamily="34" charset="0"/>
-              <a:buChar char="»"/>
-              <a:defRPr sz="2000">
-                <a:solidFill>
-                  <a:schemeClr val="tx1"/>
-                </a:solidFill>
-                <a:latin typeface="Calibri" panose="020F0502020204030204" pitchFamily="34" charset="0"/>
-              </a:defRPr>
-            </a:lvl9pPr>
-          </a:lstStyle>
-          <a:p>
-            <a:pPr marL="0" marR="0" lvl="0" indent="0" algn="l" defTabSz="914400" rtl="0" eaLnBrk="1" fontAlgn="auto" latinLnBrk="0" hangingPunct="1">
-              <a:lnSpc>
-                <a:spcPct val="100000"/>
-              </a:lnSpc>
-              <a:spcBef>
-                <a:spcPct val="0"/>
-              </a:spcBef>
-              <a:spcAft>
-                <a:spcPts val="0"/>
-              </a:spcAft>
-              <a:buClrTx/>
-              <a:buSzTx/>
-              <a:buFontTx/>
-              <a:buNone/>
-              <a:tabLst/>
-              <a:defRPr/>
-            </a:pPr>
-            <a:fld id="{71AA101E-127A-4DAF-B4E5-EFA483F29B1E}" type="slidenum">
-              <a:rPr kumimoji="0" lang="en-US" altLang="en-US" sz="1200" b="0" i="0" u="none" strike="noStrike" kern="1200" cap="none" spc="0" normalizeH="0" baseline="0" noProof="0">
-                <a:ln>
-                  <a:noFill/>
-                </a:ln>
-                <a:solidFill>
-                  <a:srgbClr val="898989"/>
-                </a:solidFill>
-                <a:effectLst/>
-                <a:uLnTx/>
-                <a:uFillTx/>
-                <a:latin typeface="Calibri" panose="020F0502020204030204" pitchFamily="34" charset="0"/>
-                <a:ea typeface="+mn-ea"/>
-                <a:cs typeface="+mn-cs"/>
-              </a:rPr>
-              <a:pPr marL="0" marR="0" lvl="0" indent="0" algn="l" defTabSz="914400" rtl="0" eaLnBrk="1" fontAlgn="auto" latinLnBrk="0" hangingPunct="1">
-                <a:lnSpc>
-                  <a:spcPct val="100000"/>
-                </a:lnSpc>
-                <a:spcBef>
-                  <a:spcPct val="0"/>
-                </a:spcBef>
-                <a:spcAft>
-                  <a:spcPts val="0"/>
-                </a:spcAft>
-                <a:buClrTx/>
-                <a:buSzTx/>
-                <a:buFontTx/>
-                <a:buNone/>
-                <a:tabLst/>
-                <a:defRPr/>
-              </a:pPr>
-              <a:t>43</a:t>
-            </a:fld>
-            <a:endParaRPr kumimoji="0" lang="en-US" altLang="en-US" sz="1200" b="0" i="0" u="none" strike="noStrike" kern="1200" cap="none" spc="0" normalizeH="0" baseline="0" noProof="0">
-              <a:ln>
-                <a:noFill/>
-              </a:ln>
-              <a:solidFill>
-                <a:srgbClr val="898989"/>
-              </a:solidFill>
-              <a:effectLst/>
-              <a:uLnTx/>
-              <a:uFillTx/>
-              <a:latin typeface="Calibri" panose="020F0502020204030204" pitchFamily="34" charset="0"/>
-              <a:ea typeface="+mn-ea"/>
-              <a:cs typeface="+mn-cs"/>
-            </a:endParaRPr>
+              <a:t>… to here …</a:t>
+            </a:r>
           </a:p>
         </p:txBody>
       </p:sp>
     </p:spTree>
     <p:extLst>
       <p:ext uri="{BB962C8B-B14F-4D97-AF65-F5344CB8AC3E}">
-        <p14:creationId xmlns:p14="http://schemas.microsoft.com/office/powerpoint/2010/main" val="3866326375"/>
+        <p14:creationId xmlns:p14="http://schemas.microsoft.com/office/powerpoint/2010/main" val="2815624037"/>
       </p:ext>
     </p:extLst>
   </p:cSld>
@@ -19185,46 +18958,195 @@
             <p:ph type="title"/>
           </p:nvPr>
         </p:nvSpPr>
-        <p:spPr>
-          <a:xfrm>
-            <a:off x="936516" y="1170297"/>
-            <a:ext cx="10417284" cy="723239"/>
-          </a:xfrm>
-        </p:spPr>
+        <p:spPr/>
         <p:txBody>
-          <a:bodyPr>
+          <a:bodyPr rtlCol="0">
             <a:normAutofit/>
           </a:bodyPr>
           <a:lstStyle/>
           <a:p>
+            <a:pPr>
+              <a:defRPr/>
+            </a:pPr>
             <a:r>
               <a:rPr lang="en-US" dirty="0"/>
-              <a:t>Paint method AWT:</a:t>
+              <a:t>Overwriting paint method (AWT)</a:t>
             </a:r>
           </a:p>
         </p:txBody>
       </p:sp>
       <p:sp>
         <p:nvSpPr>
-          <p:cNvPr id="4" name="Footer Placeholder 3"/>
+          <p:cNvPr id="5123" name="Slide Number Placeholder 3"/>
           <p:cNvSpPr>
             <a:spLocks noGrp="1"/>
           </p:cNvSpPr>
           <p:nvPr>
-            <p:ph type="ftr" sz="quarter" idx="11"/>
+            <p:ph type="sldNum" sz="quarter" idx="4294967295"/>
           </p:nvPr>
         </p:nvSpPr>
-        <p:spPr/>
+        <p:spPr bwMode="auto">
+          <a:noFill/>
+          <a:extLst>
+            <a:ext uri="{909E8E84-426E-40DD-AFC4-6F175D3DCCD1}">
+              <a14:hiddenFill xmlns:a14="http://schemas.microsoft.com/office/drawing/2010/main">
+                <a:solidFill>
+                  <a:srgbClr val="FFFFFF"/>
+                </a:solidFill>
+              </a14:hiddenFill>
+            </a:ext>
+            <a:ext uri="{91240B29-F687-4F45-9708-019B960494DF}">
+              <a14:hiddenLine xmlns:a14="http://schemas.microsoft.com/office/drawing/2010/main" w="9525">
+                <a:solidFill>
+                  <a:srgbClr val="000000"/>
+                </a:solidFill>
+                <a:miter lim="800000"/>
+                <a:headEnd/>
+                <a:tailEnd/>
+              </a14:hiddenLine>
+            </a:ext>
+          </a:extLst>
+        </p:spPr>
         <p:txBody>
           <a:bodyPr/>
-          <a:lstStyle/>
+          <a:lstStyle>
+            <a:lvl1pPr>
+              <a:spcBef>
+                <a:spcPct val="20000"/>
+              </a:spcBef>
+              <a:buFont typeface="Arial" panose="020B0604020202020204" pitchFamily="34" charset="0"/>
+              <a:buChar char="•"/>
+              <a:defRPr sz="3200">
+                <a:solidFill>
+                  <a:schemeClr val="tx1"/>
+                </a:solidFill>
+                <a:latin typeface="Calibri" panose="020F0502020204030204" pitchFamily="34" charset="0"/>
+              </a:defRPr>
+            </a:lvl1pPr>
+            <a:lvl2pPr marL="742950" indent="-285750">
+              <a:spcBef>
+                <a:spcPct val="20000"/>
+              </a:spcBef>
+              <a:buFont typeface="Arial" panose="020B0604020202020204" pitchFamily="34" charset="0"/>
+              <a:buChar char="–"/>
+              <a:defRPr sz="2800">
+                <a:solidFill>
+                  <a:schemeClr val="tx1"/>
+                </a:solidFill>
+                <a:latin typeface="Calibri" panose="020F0502020204030204" pitchFamily="34" charset="0"/>
+              </a:defRPr>
+            </a:lvl2pPr>
+            <a:lvl3pPr marL="1143000" indent="-228600">
+              <a:spcBef>
+                <a:spcPct val="20000"/>
+              </a:spcBef>
+              <a:buFont typeface="Arial" panose="020B0604020202020204" pitchFamily="34" charset="0"/>
+              <a:buChar char="•"/>
+              <a:defRPr sz="2400">
+                <a:solidFill>
+                  <a:schemeClr val="tx1"/>
+                </a:solidFill>
+                <a:latin typeface="Calibri" panose="020F0502020204030204" pitchFamily="34" charset="0"/>
+              </a:defRPr>
+            </a:lvl3pPr>
+            <a:lvl4pPr marL="1600200" indent="-228600">
+              <a:spcBef>
+                <a:spcPct val="20000"/>
+              </a:spcBef>
+              <a:buFont typeface="Arial" panose="020B0604020202020204" pitchFamily="34" charset="0"/>
+              <a:buChar char="–"/>
+              <a:defRPr sz="2000">
+                <a:solidFill>
+                  <a:schemeClr val="tx1"/>
+                </a:solidFill>
+                <a:latin typeface="Calibri" panose="020F0502020204030204" pitchFamily="34" charset="0"/>
+              </a:defRPr>
+            </a:lvl4pPr>
+            <a:lvl5pPr marL="2057400" indent="-228600">
+              <a:spcBef>
+                <a:spcPct val="20000"/>
+              </a:spcBef>
+              <a:buFont typeface="Arial" panose="020B0604020202020204" pitchFamily="34" charset="0"/>
+              <a:buChar char="»"/>
+              <a:defRPr sz="2000">
+                <a:solidFill>
+                  <a:schemeClr val="tx1"/>
+                </a:solidFill>
+                <a:latin typeface="Calibri" panose="020F0502020204030204" pitchFamily="34" charset="0"/>
+              </a:defRPr>
+            </a:lvl5pPr>
+            <a:lvl6pPr marL="2514600" indent="-228600" eaLnBrk="0" fontAlgn="base" hangingPunct="0">
+              <a:spcBef>
+                <a:spcPct val="20000"/>
+              </a:spcBef>
+              <a:spcAft>
+                <a:spcPct val="0"/>
+              </a:spcAft>
+              <a:buFont typeface="Arial" panose="020B0604020202020204" pitchFamily="34" charset="0"/>
+              <a:buChar char="»"/>
+              <a:defRPr sz="2000">
+                <a:solidFill>
+                  <a:schemeClr val="tx1"/>
+                </a:solidFill>
+                <a:latin typeface="Calibri" panose="020F0502020204030204" pitchFamily="34" charset="0"/>
+              </a:defRPr>
+            </a:lvl6pPr>
+            <a:lvl7pPr marL="2971800" indent="-228600" eaLnBrk="0" fontAlgn="base" hangingPunct="0">
+              <a:spcBef>
+                <a:spcPct val="20000"/>
+              </a:spcBef>
+              <a:spcAft>
+                <a:spcPct val="0"/>
+              </a:spcAft>
+              <a:buFont typeface="Arial" panose="020B0604020202020204" pitchFamily="34" charset="0"/>
+              <a:buChar char="»"/>
+              <a:defRPr sz="2000">
+                <a:solidFill>
+                  <a:schemeClr val="tx1"/>
+                </a:solidFill>
+                <a:latin typeface="Calibri" panose="020F0502020204030204" pitchFamily="34" charset="0"/>
+              </a:defRPr>
+            </a:lvl7pPr>
+            <a:lvl8pPr marL="3429000" indent="-228600" eaLnBrk="0" fontAlgn="base" hangingPunct="0">
+              <a:spcBef>
+                <a:spcPct val="20000"/>
+              </a:spcBef>
+              <a:spcAft>
+                <a:spcPct val="0"/>
+              </a:spcAft>
+              <a:buFont typeface="Arial" panose="020B0604020202020204" pitchFamily="34" charset="0"/>
+              <a:buChar char="»"/>
+              <a:defRPr sz="2000">
+                <a:solidFill>
+                  <a:schemeClr val="tx1"/>
+                </a:solidFill>
+                <a:latin typeface="Calibri" panose="020F0502020204030204" pitchFamily="34" charset="0"/>
+              </a:defRPr>
+            </a:lvl8pPr>
+            <a:lvl9pPr marL="3886200" indent="-228600" eaLnBrk="0" fontAlgn="base" hangingPunct="0">
+              <a:spcBef>
+                <a:spcPct val="20000"/>
+              </a:spcBef>
+              <a:spcAft>
+                <a:spcPct val="0"/>
+              </a:spcAft>
+              <a:buFont typeface="Arial" panose="020B0604020202020204" pitchFamily="34" charset="0"/>
+              <a:buChar char="»"/>
+              <a:defRPr sz="2000">
+                <a:solidFill>
+                  <a:schemeClr val="tx1"/>
+                </a:solidFill>
+                <a:latin typeface="Calibri" panose="020F0502020204030204" pitchFamily="34" charset="0"/>
+              </a:defRPr>
+            </a:lvl9pPr>
+          </a:lstStyle>
           <a:p>
             <a:pPr marL="0" marR="0" lvl="0" indent="0" algn="l" defTabSz="914400" rtl="0" eaLnBrk="1" fontAlgn="auto" latinLnBrk="0" hangingPunct="1">
               <a:lnSpc>
                 <a:spcPct val="100000"/>
               </a:lnSpc>
               <a:spcBef>
-                <a:spcPts val="0"/>
+                <a:spcPct val="0"/>
               </a:spcBef>
               <a:spcAft>
                 <a:spcPts val="0"/>
@@ -19236,70 +19158,18 @@
               <a:tabLst/>
               <a:defRPr/>
             </a:pPr>
-            <a:r>
-              <a:rPr kumimoji="0" lang="en-US" sz="1800" b="0" i="0" u="none" strike="noStrike" kern="1200" cap="none" spc="0" normalizeH="0" baseline="0" noProof="0" dirty="0">
+            <a:fld id="{71AA101E-127A-4DAF-B4E5-EFA483F29B1E}" type="slidenum">
+              <a:rPr kumimoji="0" lang="en-US" altLang="en-US" sz="1200" b="0" i="0" u="none" strike="noStrike" kern="1200" cap="none" spc="0" normalizeH="0" baseline="0" noProof="0">
                 <a:ln>
                   <a:noFill/>
                 </a:ln>
                 <a:solidFill>
-                  <a:srgbClr val="000000"/>
+                  <a:srgbClr val="898989"/>
                 </a:solidFill>
                 <a:effectLst/>
                 <a:uLnTx/>
                 <a:uFillTx/>
-                <a:latin typeface="Arial" panose="020B0604020202020204"/>
-                <a:ea typeface="+mn-ea"/>
-                <a:cs typeface="+mn-cs"/>
-              </a:rPr>
-              <a:t> </a:t>
-            </a:r>
-          </a:p>
-        </p:txBody>
-      </p:sp>
-      <p:sp>
-        <p:nvSpPr>
-          <p:cNvPr id="5" name="Slide Number Placeholder 4"/>
-          <p:cNvSpPr>
-            <a:spLocks noGrp="1"/>
-          </p:cNvSpPr>
-          <p:nvPr>
-            <p:ph type="sldNum" sz="quarter" idx="12"/>
-          </p:nvPr>
-        </p:nvSpPr>
-        <p:spPr/>
-        <p:txBody>
-          <a:bodyPr/>
-          <a:lstStyle/>
-          <a:p>
-            <a:pPr marL="0" marR="0" lvl="0" indent="0" algn="l" defTabSz="914400" rtl="0" eaLnBrk="1" fontAlgn="auto" latinLnBrk="0" hangingPunct="1">
-              <a:lnSpc>
-                <a:spcPct val="100000"/>
-              </a:lnSpc>
-              <a:spcBef>
-                <a:spcPts val="0"/>
-              </a:spcBef>
-              <a:spcAft>
-                <a:spcPts val="0"/>
-              </a:spcAft>
-              <a:buClrTx/>
-              <a:buSzTx/>
-              <a:buFontTx/>
-              <a:buNone/>
-              <a:tabLst/>
-              <a:defRPr/>
-            </a:pPr>
-            <a:fld id="{4FBCB832-F407-431A-BE08-B640AFF97906}" type="slidenum">
-              <a:rPr kumimoji="0" lang="en-US" sz="1800" b="0" i="0" u="none" strike="noStrike" kern="1200" cap="none" spc="0" normalizeH="0" baseline="0" noProof="0" smtClean="0">
-                <a:ln>
-                  <a:noFill/>
-                </a:ln>
-                <a:solidFill>
-                  <a:srgbClr val="000000"/>
-                </a:solidFill>
-                <a:effectLst/>
-                <a:uLnTx/>
-                <a:uFillTx/>
-                <a:latin typeface="Arial" panose="020B0604020202020204"/>
+                <a:latin typeface="Calibri" panose="020F0502020204030204" pitchFamily="34" charset="0"/>
                 <a:ea typeface="+mn-ea"/>
                 <a:cs typeface="+mn-cs"/>
               </a:rPr>
@@ -19308,7 +19178,7 @@
                   <a:spcPct val="100000"/>
                 </a:lnSpc>
                 <a:spcBef>
-                  <a:spcPts val="0"/>
+                  <a:spcPct val="0"/>
                 </a:spcBef>
                 <a:spcAft>
                   <a:spcPts val="0"/>
@@ -19322,463 +19192,17 @@
               </a:pPr>
               <a:t>44</a:t>
             </a:fld>
-            <a:endParaRPr kumimoji="0" lang="en-US" sz="1800" b="0" i="0" u="none" strike="noStrike" kern="1200" cap="none" spc="0" normalizeH="0" baseline="0" noProof="0" dirty="0">
+            <a:endParaRPr kumimoji="0" lang="en-US" altLang="en-US" sz="1200" b="0" i="0" u="none" strike="noStrike" kern="1200" cap="none" spc="0" normalizeH="0" baseline="0" noProof="0">
               <a:ln>
                 <a:noFill/>
               </a:ln>
               <a:solidFill>
-                <a:srgbClr val="000000"/>
+                <a:srgbClr val="898989"/>
               </a:solidFill>
               <a:effectLst/>
               <a:uLnTx/>
               <a:uFillTx/>
-              <a:latin typeface="Arial" panose="020B0604020202020204"/>
-              <a:ea typeface="+mn-ea"/>
-              <a:cs typeface="+mn-cs"/>
-            </a:endParaRPr>
-          </a:p>
-        </p:txBody>
-      </p:sp>
-      <p:sp>
-        <p:nvSpPr>
-          <p:cNvPr id="10" name="TextBox 9"/>
-          <p:cNvSpPr txBox="1"/>
-          <p:nvPr/>
-        </p:nvSpPr>
-        <p:spPr>
-          <a:xfrm>
-            <a:off x="936516" y="2146989"/>
-            <a:ext cx="3954929" cy="3416320"/>
-          </a:xfrm>
-          <a:prstGeom prst="rect">
-            <a:avLst/>
-          </a:prstGeom>
-          <a:noFill/>
-        </p:spPr>
-        <p:txBody>
-          <a:bodyPr wrap="none" rtlCol="0">
-            <a:spAutoFit/>
-          </a:bodyPr>
-          <a:lstStyle/>
-          <a:p>
-            <a:pPr marL="0" marR="0" lvl="0" indent="0" algn="l" defTabSz="914400" rtl="0" eaLnBrk="1" fontAlgn="auto" latinLnBrk="0" hangingPunct="1">
-              <a:lnSpc>
-                <a:spcPct val="100000"/>
-              </a:lnSpc>
-              <a:spcBef>
-                <a:spcPts val="0"/>
-              </a:spcBef>
-              <a:spcAft>
-                <a:spcPts val="0"/>
-              </a:spcAft>
-              <a:buClrTx/>
-              <a:buSzTx/>
-              <a:buFontTx/>
-              <a:buNone/>
-              <a:tabLst/>
-              <a:defRPr/>
-            </a:pPr>
-            <a:r>
-              <a:rPr kumimoji="0" lang="en-US" sz="1800" b="1" i="0" u="none" strike="noStrike" kern="1200" cap="none" spc="0" normalizeH="0" baseline="0" noProof="0" dirty="0">
-                <a:ln>
-                  <a:noFill/>
-                </a:ln>
-                <a:solidFill>
-                  <a:srgbClr val="000000"/>
-                </a:solidFill>
-                <a:effectLst/>
-                <a:uLnTx/>
-                <a:uFillTx/>
-                <a:latin typeface="Arial" panose="020B0604020202020204"/>
-                <a:ea typeface="+mn-ea"/>
-                <a:cs typeface="+mn-cs"/>
-              </a:rPr>
-              <a:t>Paint is called:</a:t>
-            </a:r>
-          </a:p>
-          <a:p>
-            <a:pPr marL="285750" marR="0" lvl="0" indent="-285750" algn="l" defTabSz="914400" rtl="0" eaLnBrk="1" fontAlgn="auto" latinLnBrk="0" hangingPunct="1">
-              <a:lnSpc>
-                <a:spcPct val="100000"/>
-              </a:lnSpc>
-              <a:spcBef>
-                <a:spcPts val="0"/>
-              </a:spcBef>
-              <a:spcAft>
-                <a:spcPts val="0"/>
-              </a:spcAft>
-              <a:buClrTx/>
-              <a:buSzTx/>
-              <a:buFont typeface="Arial" panose="020B0604020202020204" pitchFamily="34" charset="0"/>
-              <a:buChar char="•"/>
-              <a:tabLst/>
-              <a:defRPr/>
-            </a:pPr>
-            <a:r>
-              <a:rPr kumimoji="0" lang="en-US" sz="1800" b="0" i="0" u="none" strike="noStrike" kern="1200" cap="none" spc="0" normalizeH="0" baseline="0" noProof="0" dirty="0">
-                <a:ln>
-                  <a:noFill/>
-                </a:ln>
-                <a:solidFill>
-                  <a:srgbClr val="000000"/>
-                </a:solidFill>
-                <a:effectLst/>
-                <a:uLnTx/>
-                <a:uFillTx/>
-                <a:latin typeface="Arial" panose="020B0604020202020204"/>
-                <a:ea typeface="+mn-ea"/>
-                <a:cs typeface="+mn-cs"/>
-              </a:rPr>
-              <a:t>Screen refresh</a:t>
-            </a:r>
-          </a:p>
-          <a:p>
-            <a:pPr marL="285750" marR="0" lvl="0" indent="-285750" algn="l" defTabSz="914400" rtl="0" eaLnBrk="1" fontAlgn="auto" latinLnBrk="0" hangingPunct="1">
-              <a:lnSpc>
-                <a:spcPct val="100000"/>
-              </a:lnSpc>
-              <a:spcBef>
-                <a:spcPts val="0"/>
-              </a:spcBef>
-              <a:spcAft>
-                <a:spcPts val="0"/>
-              </a:spcAft>
-              <a:buClrTx/>
-              <a:buSzTx/>
-              <a:buFont typeface="Arial" panose="020B0604020202020204" pitchFamily="34" charset="0"/>
-              <a:buChar char="•"/>
-              <a:tabLst/>
-              <a:defRPr/>
-            </a:pPr>
-            <a:r>
-              <a:rPr kumimoji="0" lang="en-US" sz="1800" b="0" i="0" u="none" strike="noStrike" kern="1200" cap="none" spc="0" normalizeH="0" baseline="0" noProof="0" dirty="0">
-                <a:ln>
-                  <a:noFill/>
-                </a:ln>
-                <a:solidFill>
-                  <a:srgbClr val="000000"/>
-                </a:solidFill>
-                <a:effectLst/>
-                <a:uLnTx/>
-                <a:uFillTx/>
-                <a:latin typeface="Arial" panose="020B0604020202020204"/>
-                <a:ea typeface="+mn-ea"/>
-                <a:cs typeface="+mn-cs"/>
-              </a:rPr>
-              <a:t>Window update</a:t>
-            </a:r>
-          </a:p>
-          <a:p>
-            <a:pPr marL="285750" marR="0" lvl="0" indent="-285750" algn="l" defTabSz="914400" rtl="0" eaLnBrk="1" fontAlgn="auto" latinLnBrk="0" hangingPunct="1">
-              <a:lnSpc>
-                <a:spcPct val="100000"/>
-              </a:lnSpc>
-              <a:spcBef>
-                <a:spcPts val="0"/>
-              </a:spcBef>
-              <a:spcAft>
-                <a:spcPts val="0"/>
-              </a:spcAft>
-              <a:buClrTx/>
-              <a:buSzTx/>
-              <a:buFont typeface="Arial" panose="020B0604020202020204" pitchFamily="34" charset="0"/>
-              <a:buChar char="•"/>
-              <a:tabLst/>
-              <a:defRPr/>
-            </a:pPr>
-            <a:r>
-              <a:rPr kumimoji="0" lang="en-US" sz="1800" b="0" i="0" u="none" strike="noStrike" kern="1200" cap="none" spc="0" normalizeH="0" baseline="0" noProof="0" dirty="0">
-                <a:ln>
-                  <a:noFill/>
-                </a:ln>
-                <a:solidFill>
-                  <a:srgbClr val="000000"/>
-                </a:solidFill>
-                <a:effectLst/>
-                <a:uLnTx/>
-                <a:uFillTx/>
-                <a:latin typeface="Arial" panose="020B0604020202020204"/>
-                <a:ea typeface="+mn-ea"/>
-                <a:cs typeface="+mn-cs"/>
-              </a:rPr>
-              <a:t>Parts been hidden</a:t>
-            </a:r>
-          </a:p>
-          <a:p>
-            <a:pPr marL="285750" marR="0" lvl="0" indent="-285750" algn="l" defTabSz="914400" rtl="0" eaLnBrk="1" fontAlgn="auto" latinLnBrk="0" hangingPunct="1">
-              <a:lnSpc>
-                <a:spcPct val="100000"/>
-              </a:lnSpc>
-              <a:spcBef>
-                <a:spcPts val="0"/>
-              </a:spcBef>
-              <a:spcAft>
-                <a:spcPts val="0"/>
-              </a:spcAft>
-              <a:buClrTx/>
-              <a:buSzTx/>
-              <a:buFont typeface="Arial" panose="020B0604020202020204" pitchFamily="34" charset="0"/>
-              <a:buChar char="•"/>
-              <a:tabLst/>
-              <a:defRPr/>
-            </a:pPr>
-            <a:endParaRPr kumimoji="0" lang="en-US" sz="1800" b="0" i="0" u="none" strike="noStrike" kern="1200" cap="none" spc="0" normalizeH="0" baseline="0" noProof="0" dirty="0">
-              <a:ln>
-                <a:noFill/>
-              </a:ln>
-              <a:solidFill>
-                <a:srgbClr val="000000"/>
-              </a:solidFill>
-              <a:effectLst/>
-              <a:uLnTx/>
-              <a:uFillTx/>
-              <a:latin typeface="Arial" panose="020B0604020202020204"/>
-              <a:ea typeface="+mn-ea"/>
-              <a:cs typeface="+mn-cs"/>
-            </a:endParaRPr>
-          </a:p>
-          <a:p>
-            <a:pPr marL="0" marR="0" lvl="0" indent="0" algn="l" defTabSz="914400" rtl="0" eaLnBrk="1" fontAlgn="auto" latinLnBrk="0" hangingPunct="1">
-              <a:lnSpc>
-                <a:spcPct val="100000"/>
-              </a:lnSpc>
-              <a:spcBef>
-                <a:spcPts val="0"/>
-              </a:spcBef>
-              <a:spcAft>
-                <a:spcPts val="0"/>
-              </a:spcAft>
-              <a:buClrTx/>
-              <a:buSzTx/>
-              <a:buFontTx/>
-              <a:buNone/>
-              <a:tabLst/>
-              <a:defRPr/>
-            </a:pPr>
-            <a:r>
-              <a:rPr kumimoji="0" lang="en-US" sz="1800" b="1" i="0" u="none" strike="noStrike" kern="1200" cap="none" spc="0" normalizeH="0" baseline="0" noProof="0" dirty="0">
-                <a:ln>
-                  <a:noFill/>
-                </a:ln>
-                <a:solidFill>
-                  <a:srgbClr val="000000"/>
-                </a:solidFill>
-                <a:effectLst/>
-                <a:uLnTx/>
-                <a:uFillTx/>
-                <a:latin typeface="Arial" panose="020B0604020202020204"/>
-                <a:ea typeface="+mn-ea"/>
-                <a:cs typeface="+mn-cs"/>
-              </a:rPr>
-              <a:t>AWT paints:</a:t>
-            </a:r>
-          </a:p>
-          <a:p>
-            <a:pPr marL="285750" marR="0" lvl="0" indent="-285750" algn="l" defTabSz="914400" rtl="0" eaLnBrk="1" fontAlgn="auto" latinLnBrk="0" hangingPunct="1">
-              <a:lnSpc>
-                <a:spcPct val="100000"/>
-              </a:lnSpc>
-              <a:spcBef>
-                <a:spcPts val="0"/>
-              </a:spcBef>
-              <a:spcAft>
-                <a:spcPts val="0"/>
-              </a:spcAft>
-              <a:buClrTx/>
-              <a:buSzTx/>
-              <a:buFont typeface="Arial" panose="020B0604020202020204" pitchFamily="34" charset="0"/>
-              <a:buChar char="•"/>
-              <a:tabLst/>
-              <a:defRPr/>
-            </a:pPr>
-            <a:r>
-              <a:rPr kumimoji="0" lang="en-US" sz="1800" b="0" i="0" u="none" strike="noStrike" kern="1200" cap="none" spc="0" normalizeH="0" baseline="0" noProof="0" dirty="0">
-                <a:ln>
-                  <a:noFill/>
-                </a:ln>
-                <a:solidFill>
-                  <a:srgbClr val="000000"/>
-                </a:solidFill>
-                <a:effectLst/>
-                <a:uLnTx/>
-                <a:uFillTx/>
-                <a:latin typeface="Arial" panose="020B0604020202020204"/>
-                <a:ea typeface="+mn-ea"/>
-                <a:cs typeface="+mn-cs"/>
-              </a:rPr>
-              <a:t>Not very powerful</a:t>
-            </a:r>
-          </a:p>
-          <a:p>
-            <a:pPr marL="285750" marR="0" lvl="0" indent="-285750" algn="l" defTabSz="914400" rtl="0" eaLnBrk="1" fontAlgn="auto" latinLnBrk="0" hangingPunct="1">
-              <a:lnSpc>
-                <a:spcPct val="100000"/>
-              </a:lnSpc>
-              <a:spcBef>
-                <a:spcPts val="0"/>
-              </a:spcBef>
-              <a:spcAft>
-                <a:spcPts val="0"/>
-              </a:spcAft>
-              <a:buClrTx/>
-              <a:buSzTx/>
-              <a:buFont typeface="Arial" panose="020B0604020202020204" pitchFamily="34" charset="0"/>
-              <a:buChar char="•"/>
-              <a:tabLst/>
-              <a:defRPr/>
-            </a:pPr>
-            <a:r>
-              <a:rPr kumimoji="0" lang="en-US" sz="1800" b="0" i="0" u="none" strike="noStrike" kern="1200" cap="none" spc="0" normalizeH="0" baseline="0" noProof="0" dirty="0">
-                <a:ln>
-                  <a:noFill/>
-                </a:ln>
-                <a:solidFill>
-                  <a:srgbClr val="000000"/>
-                </a:solidFill>
-                <a:effectLst/>
-                <a:uLnTx/>
-                <a:uFillTx/>
-                <a:latin typeface="Arial" panose="020B0604020202020204"/>
-                <a:ea typeface="+mn-ea"/>
-                <a:cs typeface="+mn-cs"/>
-              </a:rPr>
-              <a:t>Obsolete</a:t>
-            </a:r>
-          </a:p>
-          <a:p>
-            <a:pPr marL="285750" marR="0" lvl="0" indent="-285750" algn="l" defTabSz="914400" rtl="0" eaLnBrk="1" fontAlgn="auto" latinLnBrk="0" hangingPunct="1">
-              <a:lnSpc>
-                <a:spcPct val="100000"/>
-              </a:lnSpc>
-              <a:spcBef>
-                <a:spcPts val="0"/>
-              </a:spcBef>
-              <a:spcAft>
-                <a:spcPts val="0"/>
-              </a:spcAft>
-              <a:buClrTx/>
-              <a:buSzTx/>
-              <a:buFont typeface="Arial" panose="020B0604020202020204" pitchFamily="34" charset="0"/>
-              <a:buChar char="•"/>
-              <a:tabLst/>
-              <a:defRPr/>
-            </a:pPr>
-            <a:r>
-              <a:rPr kumimoji="0" lang="en-US" sz="1800" b="0" i="0" u="none" strike="noStrike" kern="1200" cap="none" spc="0" normalizeH="0" baseline="0" noProof="0" dirty="0">
-                <a:ln>
-                  <a:noFill/>
-                </a:ln>
-                <a:solidFill>
-                  <a:srgbClr val="000000"/>
-                </a:solidFill>
-                <a:effectLst/>
-                <a:uLnTx/>
-                <a:uFillTx/>
-                <a:latin typeface="Arial" panose="020B0604020202020204"/>
-                <a:ea typeface="+mn-ea"/>
-                <a:cs typeface="+mn-cs"/>
-              </a:rPr>
-              <a:t>For simple drawings ok</a:t>
-            </a:r>
-          </a:p>
-          <a:p>
-            <a:pPr marL="0" marR="0" lvl="0" indent="0" algn="l" defTabSz="914400" rtl="0" eaLnBrk="1" fontAlgn="auto" latinLnBrk="0" hangingPunct="1">
-              <a:lnSpc>
-                <a:spcPct val="100000"/>
-              </a:lnSpc>
-              <a:spcBef>
-                <a:spcPts val="0"/>
-              </a:spcBef>
-              <a:spcAft>
-                <a:spcPts val="0"/>
-              </a:spcAft>
-              <a:buClrTx/>
-              <a:buSzTx/>
-              <a:buFontTx/>
-              <a:buNone/>
-              <a:tabLst/>
-              <a:defRPr/>
-            </a:pPr>
-            <a:endParaRPr kumimoji="0" lang="en-US" sz="1800" b="0" i="0" u="none" strike="noStrike" kern="1200" cap="none" spc="0" normalizeH="0" baseline="0" noProof="0" dirty="0">
-              <a:ln>
-                <a:noFill/>
-              </a:ln>
-              <a:solidFill>
-                <a:srgbClr val="000000"/>
-              </a:solidFill>
-              <a:effectLst/>
-              <a:uLnTx/>
-              <a:uFillTx/>
-              <a:latin typeface="Arial" panose="020B0604020202020204"/>
-              <a:ea typeface="+mn-ea"/>
-              <a:cs typeface="+mn-cs"/>
-            </a:endParaRPr>
-          </a:p>
-          <a:p>
-            <a:pPr marL="0" marR="0" lvl="0" indent="0" algn="l" defTabSz="914400" rtl="0" eaLnBrk="1" fontAlgn="auto" latinLnBrk="0" hangingPunct="1">
-              <a:lnSpc>
-                <a:spcPct val="100000"/>
-              </a:lnSpc>
-              <a:spcBef>
-                <a:spcPts val="0"/>
-              </a:spcBef>
-              <a:spcAft>
-                <a:spcPts val="0"/>
-              </a:spcAft>
-              <a:buClrTx/>
-              <a:buSzTx/>
-              <a:buFontTx/>
-              <a:buNone/>
-              <a:tabLst/>
-              <a:defRPr/>
-            </a:pPr>
-            <a:r>
-              <a:rPr kumimoji="0" lang="en-US" sz="1800" b="0" i="0" u="none" strike="noStrike" kern="1200" cap="none" spc="0" normalizeH="0" baseline="0" noProof="0" dirty="0">
-                <a:ln>
-                  <a:noFill/>
-                </a:ln>
-                <a:solidFill>
-                  <a:srgbClr val="FF0000"/>
-                </a:solidFill>
-                <a:effectLst/>
-                <a:uLnTx/>
-                <a:uFillTx/>
-                <a:latin typeface="Arial" panose="020B0604020202020204"/>
-                <a:ea typeface="+mn-ea"/>
-                <a:cs typeface="+mn-cs"/>
-              </a:rPr>
-              <a:t>Don’t mix it up too much with Swing</a:t>
-            </a:r>
-          </a:p>
-          <a:p>
-            <a:pPr marL="285750" marR="0" lvl="0" indent="-285750" algn="l" defTabSz="914400" rtl="0" eaLnBrk="1" fontAlgn="auto" latinLnBrk="0" hangingPunct="1">
-              <a:lnSpc>
-                <a:spcPct val="100000"/>
-              </a:lnSpc>
-              <a:spcBef>
-                <a:spcPts val="0"/>
-              </a:spcBef>
-              <a:spcAft>
-                <a:spcPts val="0"/>
-              </a:spcAft>
-              <a:buClrTx/>
-              <a:buSzTx/>
-              <a:buFont typeface="Arial" panose="020B0604020202020204" pitchFamily="34" charset="0"/>
-              <a:buChar char="•"/>
-              <a:tabLst/>
-              <a:defRPr/>
-            </a:pPr>
-            <a:endParaRPr kumimoji="0" lang="en-US" sz="1800" b="0" i="0" u="none" strike="noStrike" kern="1200" cap="none" spc="0" normalizeH="0" baseline="0" noProof="0" dirty="0">
-              <a:ln>
-                <a:noFill/>
-              </a:ln>
-              <a:solidFill>
-                <a:srgbClr val="000000"/>
-              </a:solidFill>
-              <a:effectLst/>
-              <a:uLnTx/>
-              <a:uFillTx/>
-              <a:latin typeface="Arial" panose="020B0604020202020204"/>
+              <a:latin typeface="Calibri" panose="020F0502020204030204" pitchFamily="34" charset="0"/>
               <a:ea typeface="+mn-ea"/>
               <a:cs typeface="+mn-cs"/>
             </a:endParaRPr>
@@ -19788,7 +19212,7 @@
     </p:spTree>
     <p:extLst>
       <p:ext uri="{BB962C8B-B14F-4D97-AF65-F5344CB8AC3E}">
-        <p14:creationId xmlns:p14="http://schemas.microsoft.com/office/powerpoint/2010/main" val="3787102832"/>
+        <p14:creationId xmlns:p14="http://schemas.microsoft.com/office/powerpoint/2010/main" val="3866326375"/>
       </p:ext>
     </p:extLst>
   </p:cSld>
@@ -19839,7 +19263,7 @@
           <a:p>
             <a:r>
               <a:rPr lang="en-US" dirty="0"/>
-              <a:t>Paint method example:</a:t>
+              <a:t>Paint method AWT:</a:t>
             </a:r>
           </a:p>
         </p:txBody>
@@ -19961,6 +19385,646 @@
                 <a:defRPr/>
               </a:pPr>
               <a:t>45</a:t>
+            </a:fld>
+            <a:endParaRPr kumimoji="0" lang="en-US" sz="1800" b="0" i="0" u="none" strike="noStrike" kern="1200" cap="none" spc="0" normalizeH="0" baseline="0" noProof="0" dirty="0">
+              <a:ln>
+                <a:noFill/>
+              </a:ln>
+              <a:solidFill>
+                <a:srgbClr val="000000"/>
+              </a:solidFill>
+              <a:effectLst/>
+              <a:uLnTx/>
+              <a:uFillTx/>
+              <a:latin typeface="Arial" panose="020B0604020202020204"/>
+              <a:ea typeface="+mn-ea"/>
+              <a:cs typeface="+mn-cs"/>
+            </a:endParaRPr>
+          </a:p>
+        </p:txBody>
+      </p:sp>
+      <p:sp>
+        <p:nvSpPr>
+          <p:cNvPr id="10" name="TextBox 9"/>
+          <p:cNvSpPr txBox="1"/>
+          <p:nvPr/>
+        </p:nvSpPr>
+        <p:spPr>
+          <a:xfrm>
+            <a:off x="936516" y="2146989"/>
+            <a:ext cx="3954929" cy="3416320"/>
+          </a:xfrm>
+          <a:prstGeom prst="rect">
+            <a:avLst/>
+          </a:prstGeom>
+          <a:noFill/>
+        </p:spPr>
+        <p:txBody>
+          <a:bodyPr wrap="none" rtlCol="0">
+            <a:spAutoFit/>
+          </a:bodyPr>
+          <a:lstStyle/>
+          <a:p>
+            <a:pPr marL="0" marR="0" lvl="0" indent="0" algn="l" defTabSz="914400" rtl="0" eaLnBrk="1" fontAlgn="auto" latinLnBrk="0" hangingPunct="1">
+              <a:lnSpc>
+                <a:spcPct val="100000"/>
+              </a:lnSpc>
+              <a:spcBef>
+                <a:spcPts val="0"/>
+              </a:spcBef>
+              <a:spcAft>
+                <a:spcPts val="0"/>
+              </a:spcAft>
+              <a:buClrTx/>
+              <a:buSzTx/>
+              <a:buFontTx/>
+              <a:buNone/>
+              <a:tabLst/>
+              <a:defRPr/>
+            </a:pPr>
+            <a:r>
+              <a:rPr kumimoji="0" lang="en-US" sz="1800" b="1" i="0" u="none" strike="noStrike" kern="1200" cap="none" spc="0" normalizeH="0" baseline="0" noProof="0" dirty="0">
+                <a:ln>
+                  <a:noFill/>
+                </a:ln>
+                <a:solidFill>
+                  <a:srgbClr val="000000"/>
+                </a:solidFill>
+                <a:effectLst/>
+                <a:uLnTx/>
+                <a:uFillTx/>
+                <a:latin typeface="Arial" panose="020B0604020202020204"/>
+                <a:ea typeface="+mn-ea"/>
+                <a:cs typeface="+mn-cs"/>
+              </a:rPr>
+              <a:t>Paint is called:</a:t>
+            </a:r>
+          </a:p>
+          <a:p>
+            <a:pPr marL="285750" marR="0" lvl="0" indent="-285750" algn="l" defTabSz="914400" rtl="0" eaLnBrk="1" fontAlgn="auto" latinLnBrk="0" hangingPunct="1">
+              <a:lnSpc>
+                <a:spcPct val="100000"/>
+              </a:lnSpc>
+              <a:spcBef>
+                <a:spcPts val="0"/>
+              </a:spcBef>
+              <a:spcAft>
+                <a:spcPts val="0"/>
+              </a:spcAft>
+              <a:buClrTx/>
+              <a:buSzTx/>
+              <a:buFont typeface="Arial" panose="020B0604020202020204" pitchFamily="34" charset="0"/>
+              <a:buChar char="•"/>
+              <a:tabLst/>
+              <a:defRPr/>
+            </a:pPr>
+            <a:r>
+              <a:rPr kumimoji="0" lang="en-US" sz="1800" b="0" i="0" u="none" strike="noStrike" kern="1200" cap="none" spc="0" normalizeH="0" baseline="0" noProof="0" dirty="0">
+                <a:ln>
+                  <a:noFill/>
+                </a:ln>
+                <a:solidFill>
+                  <a:srgbClr val="000000"/>
+                </a:solidFill>
+                <a:effectLst/>
+                <a:uLnTx/>
+                <a:uFillTx/>
+                <a:latin typeface="Arial" panose="020B0604020202020204"/>
+                <a:ea typeface="+mn-ea"/>
+                <a:cs typeface="+mn-cs"/>
+              </a:rPr>
+              <a:t>Screen refresh</a:t>
+            </a:r>
+          </a:p>
+          <a:p>
+            <a:pPr marL="285750" marR="0" lvl="0" indent="-285750" algn="l" defTabSz="914400" rtl="0" eaLnBrk="1" fontAlgn="auto" latinLnBrk="0" hangingPunct="1">
+              <a:lnSpc>
+                <a:spcPct val="100000"/>
+              </a:lnSpc>
+              <a:spcBef>
+                <a:spcPts val="0"/>
+              </a:spcBef>
+              <a:spcAft>
+                <a:spcPts val="0"/>
+              </a:spcAft>
+              <a:buClrTx/>
+              <a:buSzTx/>
+              <a:buFont typeface="Arial" panose="020B0604020202020204" pitchFamily="34" charset="0"/>
+              <a:buChar char="•"/>
+              <a:tabLst/>
+              <a:defRPr/>
+            </a:pPr>
+            <a:r>
+              <a:rPr kumimoji="0" lang="en-US" sz="1800" b="0" i="0" u="none" strike="noStrike" kern="1200" cap="none" spc="0" normalizeH="0" baseline="0" noProof="0" dirty="0">
+                <a:ln>
+                  <a:noFill/>
+                </a:ln>
+                <a:solidFill>
+                  <a:srgbClr val="000000"/>
+                </a:solidFill>
+                <a:effectLst/>
+                <a:uLnTx/>
+                <a:uFillTx/>
+                <a:latin typeface="Arial" panose="020B0604020202020204"/>
+                <a:ea typeface="+mn-ea"/>
+                <a:cs typeface="+mn-cs"/>
+              </a:rPr>
+              <a:t>Window update</a:t>
+            </a:r>
+          </a:p>
+          <a:p>
+            <a:pPr marL="285750" marR="0" lvl="0" indent="-285750" algn="l" defTabSz="914400" rtl="0" eaLnBrk="1" fontAlgn="auto" latinLnBrk="0" hangingPunct="1">
+              <a:lnSpc>
+                <a:spcPct val="100000"/>
+              </a:lnSpc>
+              <a:spcBef>
+                <a:spcPts val="0"/>
+              </a:spcBef>
+              <a:spcAft>
+                <a:spcPts val="0"/>
+              </a:spcAft>
+              <a:buClrTx/>
+              <a:buSzTx/>
+              <a:buFont typeface="Arial" panose="020B0604020202020204" pitchFamily="34" charset="0"/>
+              <a:buChar char="•"/>
+              <a:tabLst/>
+              <a:defRPr/>
+            </a:pPr>
+            <a:r>
+              <a:rPr kumimoji="0" lang="en-US" sz="1800" b="0" i="0" u="none" strike="noStrike" kern="1200" cap="none" spc="0" normalizeH="0" baseline="0" noProof="0" dirty="0">
+                <a:ln>
+                  <a:noFill/>
+                </a:ln>
+                <a:solidFill>
+                  <a:srgbClr val="000000"/>
+                </a:solidFill>
+                <a:effectLst/>
+                <a:uLnTx/>
+                <a:uFillTx/>
+                <a:latin typeface="Arial" panose="020B0604020202020204"/>
+                <a:ea typeface="+mn-ea"/>
+                <a:cs typeface="+mn-cs"/>
+              </a:rPr>
+              <a:t>Parts been hidden</a:t>
+            </a:r>
+          </a:p>
+          <a:p>
+            <a:pPr marL="285750" marR="0" lvl="0" indent="-285750" algn="l" defTabSz="914400" rtl="0" eaLnBrk="1" fontAlgn="auto" latinLnBrk="0" hangingPunct="1">
+              <a:lnSpc>
+                <a:spcPct val="100000"/>
+              </a:lnSpc>
+              <a:spcBef>
+                <a:spcPts val="0"/>
+              </a:spcBef>
+              <a:spcAft>
+                <a:spcPts val="0"/>
+              </a:spcAft>
+              <a:buClrTx/>
+              <a:buSzTx/>
+              <a:buFont typeface="Arial" panose="020B0604020202020204" pitchFamily="34" charset="0"/>
+              <a:buChar char="•"/>
+              <a:tabLst/>
+              <a:defRPr/>
+            </a:pPr>
+            <a:endParaRPr kumimoji="0" lang="en-US" sz="1800" b="0" i="0" u="none" strike="noStrike" kern="1200" cap="none" spc="0" normalizeH="0" baseline="0" noProof="0" dirty="0">
+              <a:ln>
+                <a:noFill/>
+              </a:ln>
+              <a:solidFill>
+                <a:srgbClr val="000000"/>
+              </a:solidFill>
+              <a:effectLst/>
+              <a:uLnTx/>
+              <a:uFillTx/>
+              <a:latin typeface="Arial" panose="020B0604020202020204"/>
+              <a:ea typeface="+mn-ea"/>
+              <a:cs typeface="+mn-cs"/>
+            </a:endParaRPr>
+          </a:p>
+          <a:p>
+            <a:pPr marL="0" marR="0" lvl="0" indent="0" algn="l" defTabSz="914400" rtl="0" eaLnBrk="1" fontAlgn="auto" latinLnBrk="0" hangingPunct="1">
+              <a:lnSpc>
+                <a:spcPct val="100000"/>
+              </a:lnSpc>
+              <a:spcBef>
+                <a:spcPts val="0"/>
+              </a:spcBef>
+              <a:spcAft>
+                <a:spcPts val="0"/>
+              </a:spcAft>
+              <a:buClrTx/>
+              <a:buSzTx/>
+              <a:buFontTx/>
+              <a:buNone/>
+              <a:tabLst/>
+              <a:defRPr/>
+            </a:pPr>
+            <a:r>
+              <a:rPr kumimoji="0" lang="en-US" sz="1800" b="1" i="0" u="none" strike="noStrike" kern="1200" cap="none" spc="0" normalizeH="0" baseline="0" noProof="0" dirty="0">
+                <a:ln>
+                  <a:noFill/>
+                </a:ln>
+                <a:solidFill>
+                  <a:srgbClr val="000000"/>
+                </a:solidFill>
+                <a:effectLst/>
+                <a:uLnTx/>
+                <a:uFillTx/>
+                <a:latin typeface="Arial" panose="020B0604020202020204"/>
+                <a:ea typeface="+mn-ea"/>
+                <a:cs typeface="+mn-cs"/>
+              </a:rPr>
+              <a:t>AWT paints:</a:t>
+            </a:r>
+          </a:p>
+          <a:p>
+            <a:pPr marL="285750" marR="0" lvl="0" indent="-285750" algn="l" defTabSz="914400" rtl="0" eaLnBrk="1" fontAlgn="auto" latinLnBrk="0" hangingPunct="1">
+              <a:lnSpc>
+                <a:spcPct val="100000"/>
+              </a:lnSpc>
+              <a:spcBef>
+                <a:spcPts val="0"/>
+              </a:spcBef>
+              <a:spcAft>
+                <a:spcPts val="0"/>
+              </a:spcAft>
+              <a:buClrTx/>
+              <a:buSzTx/>
+              <a:buFont typeface="Arial" panose="020B0604020202020204" pitchFamily="34" charset="0"/>
+              <a:buChar char="•"/>
+              <a:tabLst/>
+              <a:defRPr/>
+            </a:pPr>
+            <a:r>
+              <a:rPr kumimoji="0" lang="en-US" sz="1800" b="0" i="0" u="none" strike="noStrike" kern="1200" cap="none" spc="0" normalizeH="0" baseline="0" noProof="0" dirty="0">
+                <a:ln>
+                  <a:noFill/>
+                </a:ln>
+                <a:solidFill>
+                  <a:srgbClr val="000000"/>
+                </a:solidFill>
+                <a:effectLst/>
+                <a:uLnTx/>
+                <a:uFillTx/>
+                <a:latin typeface="Arial" panose="020B0604020202020204"/>
+                <a:ea typeface="+mn-ea"/>
+                <a:cs typeface="+mn-cs"/>
+              </a:rPr>
+              <a:t>Not very powerful</a:t>
+            </a:r>
+          </a:p>
+          <a:p>
+            <a:pPr marL="285750" marR="0" lvl="0" indent="-285750" algn="l" defTabSz="914400" rtl="0" eaLnBrk="1" fontAlgn="auto" latinLnBrk="0" hangingPunct="1">
+              <a:lnSpc>
+                <a:spcPct val="100000"/>
+              </a:lnSpc>
+              <a:spcBef>
+                <a:spcPts val="0"/>
+              </a:spcBef>
+              <a:spcAft>
+                <a:spcPts val="0"/>
+              </a:spcAft>
+              <a:buClrTx/>
+              <a:buSzTx/>
+              <a:buFont typeface="Arial" panose="020B0604020202020204" pitchFamily="34" charset="0"/>
+              <a:buChar char="•"/>
+              <a:tabLst/>
+              <a:defRPr/>
+            </a:pPr>
+            <a:r>
+              <a:rPr kumimoji="0" lang="en-US" sz="1800" b="0" i="0" u="none" strike="noStrike" kern="1200" cap="none" spc="0" normalizeH="0" baseline="0" noProof="0" dirty="0">
+                <a:ln>
+                  <a:noFill/>
+                </a:ln>
+                <a:solidFill>
+                  <a:srgbClr val="000000"/>
+                </a:solidFill>
+                <a:effectLst/>
+                <a:uLnTx/>
+                <a:uFillTx/>
+                <a:latin typeface="Arial" panose="020B0604020202020204"/>
+                <a:ea typeface="+mn-ea"/>
+                <a:cs typeface="+mn-cs"/>
+              </a:rPr>
+              <a:t>Obsolete</a:t>
+            </a:r>
+          </a:p>
+          <a:p>
+            <a:pPr marL="285750" marR="0" lvl="0" indent="-285750" algn="l" defTabSz="914400" rtl="0" eaLnBrk="1" fontAlgn="auto" latinLnBrk="0" hangingPunct="1">
+              <a:lnSpc>
+                <a:spcPct val="100000"/>
+              </a:lnSpc>
+              <a:spcBef>
+                <a:spcPts val="0"/>
+              </a:spcBef>
+              <a:spcAft>
+                <a:spcPts val="0"/>
+              </a:spcAft>
+              <a:buClrTx/>
+              <a:buSzTx/>
+              <a:buFont typeface="Arial" panose="020B0604020202020204" pitchFamily="34" charset="0"/>
+              <a:buChar char="•"/>
+              <a:tabLst/>
+              <a:defRPr/>
+            </a:pPr>
+            <a:r>
+              <a:rPr kumimoji="0" lang="en-US" sz="1800" b="0" i="0" u="none" strike="noStrike" kern="1200" cap="none" spc="0" normalizeH="0" baseline="0" noProof="0" dirty="0">
+                <a:ln>
+                  <a:noFill/>
+                </a:ln>
+                <a:solidFill>
+                  <a:srgbClr val="000000"/>
+                </a:solidFill>
+                <a:effectLst/>
+                <a:uLnTx/>
+                <a:uFillTx/>
+                <a:latin typeface="Arial" panose="020B0604020202020204"/>
+                <a:ea typeface="+mn-ea"/>
+                <a:cs typeface="+mn-cs"/>
+              </a:rPr>
+              <a:t>For simple drawings ok</a:t>
+            </a:r>
+          </a:p>
+          <a:p>
+            <a:pPr marL="0" marR="0" lvl="0" indent="0" algn="l" defTabSz="914400" rtl="0" eaLnBrk="1" fontAlgn="auto" latinLnBrk="0" hangingPunct="1">
+              <a:lnSpc>
+                <a:spcPct val="100000"/>
+              </a:lnSpc>
+              <a:spcBef>
+                <a:spcPts val="0"/>
+              </a:spcBef>
+              <a:spcAft>
+                <a:spcPts val="0"/>
+              </a:spcAft>
+              <a:buClrTx/>
+              <a:buSzTx/>
+              <a:buFontTx/>
+              <a:buNone/>
+              <a:tabLst/>
+              <a:defRPr/>
+            </a:pPr>
+            <a:endParaRPr kumimoji="0" lang="en-US" sz="1800" b="0" i="0" u="none" strike="noStrike" kern="1200" cap="none" spc="0" normalizeH="0" baseline="0" noProof="0" dirty="0">
+              <a:ln>
+                <a:noFill/>
+              </a:ln>
+              <a:solidFill>
+                <a:srgbClr val="000000"/>
+              </a:solidFill>
+              <a:effectLst/>
+              <a:uLnTx/>
+              <a:uFillTx/>
+              <a:latin typeface="Arial" panose="020B0604020202020204"/>
+              <a:ea typeface="+mn-ea"/>
+              <a:cs typeface="+mn-cs"/>
+            </a:endParaRPr>
+          </a:p>
+          <a:p>
+            <a:pPr marL="0" marR="0" lvl="0" indent="0" algn="l" defTabSz="914400" rtl="0" eaLnBrk="1" fontAlgn="auto" latinLnBrk="0" hangingPunct="1">
+              <a:lnSpc>
+                <a:spcPct val="100000"/>
+              </a:lnSpc>
+              <a:spcBef>
+                <a:spcPts val="0"/>
+              </a:spcBef>
+              <a:spcAft>
+                <a:spcPts val="0"/>
+              </a:spcAft>
+              <a:buClrTx/>
+              <a:buSzTx/>
+              <a:buFontTx/>
+              <a:buNone/>
+              <a:tabLst/>
+              <a:defRPr/>
+            </a:pPr>
+            <a:r>
+              <a:rPr kumimoji="0" lang="en-US" sz="1800" b="0" i="0" u="none" strike="noStrike" kern="1200" cap="none" spc="0" normalizeH="0" baseline="0" noProof="0" dirty="0">
+                <a:ln>
+                  <a:noFill/>
+                </a:ln>
+                <a:solidFill>
+                  <a:srgbClr val="FF0000"/>
+                </a:solidFill>
+                <a:effectLst/>
+                <a:uLnTx/>
+                <a:uFillTx/>
+                <a:latin typeface="Arial" panose="020B0604020202020204"/>
+                <a:ea typeface="+mn-ea"/>
+                <a:cs typeface="+mn-cs"/>
+              </a:rPr>
+              <a:t>Don’t mix it up too much with Swing</a:t>
+            </a:r>
+          </a:p>
+          <a:p>
+            <a:pPr marL="285750" marR="0" lvl="0" indent="-285750" algn="l" defTabSz="914400" rtl="0" eaLnBrk="1" fontAlgn="auto" latinLnBrk="0" hangingPunct="1">
+              <a:lnSpc>
+                <a:spcPct val="100000"/>
+              </a:lnSpc>
+              <a:spcBef>
+                <a:spcPts val="0"/>
+              </a:spcBef>
+              <a:spcAft>
+                <a:spcPts val="0"/>
+              </a:spcAft>
+              <a:buClrTx/>
+              <a:buSzTx/>
+              <a:buFont typeface="Arial" panose="020B0604020202020204" pitchFamily="34" charset="0"/>
+              <a:buChar char="•"/>
+              <a:tabLst/>
+              <a:defRPr/>
+            </a:pPr>
+            <a:endParaRPr kumimoji="0" lang="en-US" sz="1800" b="0" i="0" u="none" strike="noStrike" kern="1200" cap="none" spc="0" normalizeH="0" baseline="0" noProof="0" dirty="0">
+              <a:ln>
+                <a:noFill/>
+              </a:ln>
+              <a:solidFill>
+                <a:srgbClr val="000000"/>
+              </a:solidFill>
+              <a:effectLst/>
+              <a:uLnTx/>
+              <a:uFillTx/>
+              <a:latin typeface="Arial" panose="020B0604020202020204"/>
+              <a:ea typeface="+mn-ea"/>
+              <a:cs typeface="+mn-cs"/>
+            </a:endParaRPr>
+          </a:p>
+        </p:txBody>
+      </p:sp>
+    </p:spTree>
+    <p:extLst>
+      <p:ext uri="{BB962C8B-B14F-4D97-AF65-F5344CB8AC3E}">
+        <p14:creationId xmlns:p14="http://schemas.microsoft.com/office/powerpoint/2010/main" val="3787102832"/>
+      </p:ext>
+    </p:extLst>
+  </p:cSld>
+  <p:clrMapOvr>
+    <a:masterClrMapping/>
+  </p:clrMapOvr>
+</p:sld>
+</file>
+
+<file path=ppt/slides/slide46.xml><?xml version="1.0" encoding="utf-8"?>
+<p:sld xmlns:a="http://schemas.openxmlformats.org/drawingml/2006/main" xmlns:r="http://schemas.openxmlformats.org/officeDocument/2006/relationships" xmlns:p="http://schemas.openxmlformats.org/presentationml/2006/main">
+  <p:cSld>
+    <p:spTree>
+      <p:nvGrpSpPr>
+        <p:cNvPr id="1" name=""/>
+        <p:cNvGrpSpPr/>
+        <p:nvPr/>
+      </p:nvGrpSpPr>
+      <p:grpSpPr>
+        <a:xfrm>
+          <a:off x="0" y="0"/>
+          <a:ext cx="0" cy="0"/>
+          <a:chOff x="0" y="0"/>
+          <a:chExt cx="0" cy="0"/>
+        </a:xfrm>
+      </p:grpSpPr>
+      <p:sp>
+        <p:nvSpPr>
+          <p:cNvPr id="2" name="Title 1"/>
+          <p:cNvSpPr>
+            <a:spLocks noGrp="1"/>
+          </p:cNvSpPr>
+          <p:nvPr>
+            <p:ph type="title"/>
+          </p:nvPr>
+        </p:nvSpPr>
+        <p:spPr>
+          <a:xfrm>
+            <a:off x="936516" y="1170297"/>
+            <a:ext cx="10417284" cy="723239"/>
+          </a:xfrm>
+        </p:spPr>
+        <p:txBody>
+          <a:bodyPr>
+            <a:normAutofit/>
+          </a:bodyPr>
+          <a:lstStyle/>
+          <a:p>
+            <a:r>
+              <a:rPr lang="en-US" dirty="0"/>
+              <a:t>Paint method example:</a:t>
+            </a:r>
+          </a:p>
+        </p:txBody>
+      </p:sp>
+      <p:sp>
+        <p:nvSpPr>
+          <p:cNvPr id="4" name="Footer Placeholder 3"/>
+          <p:cNvSpPr>
+            <a:spLocks noGrp="1"/>
+          </p:cNvSpPr>
+          <p:nvPr>
+            <p:ph type="ftr" sz="quarter" idx="11"/>
+          </p:nvPr>
+        </p:nvSpPr>
+        <p:spPr/>
+        <p:txBody>
+          <a:bodyPr/>
+          <a:lstStyle/>
+          <a:p>
+            <a:pPr marL="0" marR="0" lvl="0" indent="0" algn="l" defTabSz="914400" rtl="0" eaLnBrk="1" fontAlgn="auto" latinLnBrk="0" hangingPunct="1">
+              <a:lnSpc>
+                <a:spcPct val="100000"/>
+              </a:lnSpc>
+              <a:spcBef>
+                <a:spcPts val="0"/>
+              </a:spcBef>
+              <a:spcAft>
+                <a:spcPts val="0"/>
+              </a:spcAft>
+              <a:buClrTx/>
+              <a:buSzTx/>
+              <a:buFontTx/>
+              <a:buNone/>
+              <a:tabLst/>
+              <a:defRPr/>
+            </a:pPr>
+            <a:r>
+              <a:rPr kumimoji="0" lang="en-US" sz="1800" b="0" i="0" u="none" strike="noStrike" kern="1200" cap="none" spc="0" normalizeH="0" baseline="0" noProof="0" dirty="0">
+                <a:ln>
+                  <a:noFill/>
+                </a:ln>
+                <a:solidFill>
+                  <a:srgbClr val="000000"/>
+                </a:solidFill>
+                <a:effectLst/>
+                <a:uLnTx/>
+                <a:uFillTx/>
+                <a:latin typeface="Arial" panose="020B0604020202020204"/>
+                <a:ea typeface="+mn-ea"/>
+                <a:cs typeface="+mn-cs"/>
+              </a:rPr>
+              <a:t> </a:t>
+            </a:r>
+          </a:p>
+        </p:txBody>
+      </p:sp>
+      <p:sp>
+        <p:nvSpPr>
+          <p:cNvPr id="5" name="Slide Number Placeholder 4"/>
+          <p:cNvSpPr>
+            <a:spLocks noGrp="1"/>
+          </p:cNvSpPr>
+          <p:nvPr>
+            <p:ph type="sldNum" sz="quarter" idx="12"/>
+          </p:nvPr>
+        </p:nvSpPr>
+        <p:spPr/>
+        <p:txBody>
+          <a:bodyPr/>
+          <a:lstStyle/>
+          <a:p>
+            <a:pPr marL="0" marR="0" lvl="0" indent="0" algn="l" defTabSz="914400" rtl="0" eaLnBrk="1" fontAlgn="auto" latinLnBrk="0" hangingPunct="1">
+              <a:lnSpc>
+                <a:spcPct val="100000"/>
+              </a:lnSpc>
+              <a:spcBef>
+                <a:spcPts val="0"/>
+              </a:spcBef>
+              <a:spcAft>
+                <a:spcPts val="0"/>
+              </a:spcAft>
+              <a:buClrTx/>
+              <a:buSzTx/>
+              <a:buFontTx/>
+              <a:buNone/>
+              <a:tabLst/>
+              <a:defRPr/>
+            </a:pPr>
+            <a:fld id="{4FBCB832-F407-431A-BE08-B640AFF97906}" type="slidenum">
+              <a:rPr kumimoji="0" lang="en-US" sz="1800" b="0" i="0" u="none" strike="noStrike" kern="1200" cap="none" spc="0" normalizeH="0" baseline="0" noProof="0" smtClean="0">
+                <a:ln>
+                  <a:noFill/>
+                </a:ln>
+                <a:solidFill>
+                  <a:srgbClr val="000000"/>
+                </a:solidFill>
+                <a:effectLst/>
+                <a:uLnTx/>
+                <a:uFillTx/>
+                <a:latin typeface="Arial" panose="020B0604020202020204"/>
+                <a:ea typeface="+mn-ea"/>
+                <a:cs typeface="+mn-cs"/>
+              </a:rPr>
+              <a:pPr marL="0" marR="0" lvl="0" indent="0" algn="l" defTabSz="914400" rtl="0" eaLnBrk="1" fontAlgn="auto" latinLnBrk="0" hangingPunct="1">
+                <a:lnSpc>
+                  <a:spcPct val="100000"/>
+                </a:lnSpc>
+                <a:spcBef>
+                  <a:spcPts val="0"/>
+                </a:spcBef>
+                <a:spcAft>
+                  <a:spcPts val="0"/>
+                </a:spcAft>
+                <a:buClrTx/>
+                <a:buSzTx/>
+                <a:buFontTx/>
+                <a:buNone/>
+                <a:tabLst/>
+                <a:defRPr/>
+              </a:pPr>
+              <a:t>46</a:t>
             </a:fld>
             <a:endParaRPr kumimoji="0" lang="en-US" sz="1800" b="0" i="0" u="none" strike="noStrike" kern="1200" cap="none" spc="0" normalizeH="0" baseline="0" noProof="0" dirty="0">
               <a:ln>
@@ -20214,7 +20278,7 @@
 </p:sld>
 </file>
 
-<file path=ppt/slides/slide46.xml><?xml version="1.0" encoding="utf-8"?>
+<file path=ppt/slides/slide47.xml><?xml version="1.0" encoding="utf-8"?>
 <p:sld xmlns:a="http://schemas.openxmlformats.org/drawingml/2006/main" xmlns:r="http://schemas.openxmlformats.org/officeDocument/2006/relationships" xmlns:p="http://schemas.openxmlformats.org/presentationml/2006/main">
   <p:cSld>
     <p:spTree>
@@ -20376,7 +20440,7 @@
                 <a:tabLst/>
                 <a:defRPr/>
               </a:pPr>
-              <a:t>46</a:t>
+              <a:t>47</a:t>
             </a:fld>
             <a:endParaRPr kumimoji="0" lang="en-US" sz="1800" b="0" i="0" u="none" strike="noStrike" kern="1200" cap="none" spc="0" normalizeH="0" baseline="0" noProof="0" dirty="0">
               <a:ln>
@@ -20432,7 +20496,7 @@
 </p:sld>
 </file>
 
-<file path=ppt/slides/slide47.xml><?xml version="1.0" encoding="utf-8"?>
+<file path=ppt/slides/slide48.xml><?xml version="1.0" encoding="utf-8"?>
 <p:sld xmlns:a="http://schemas.openxmlformats.org/drawingml/2006/main" xmlns:r="http://schemas.openxmlformats.org/officeDocument/2006/relationships" xmlns:p="http://schemas.openxmlformats.org/presentationml/2006/main">
   <p:cSld>
     <p:spTree>
@@ -20594,7 +20658,7 @@
                 <a:tabLst/>
                 <a:defRPr/>
               </a:pPr>
-              <a:t>47</a:t>
+              <a:t>48</a:t>
             </a:fld>
             <a:endParaRPr kumimoji="0" lang="en-US" sz="1800" b="0" i="0" u="none" strike="noStrike" kern="1200" cap="none" spc="0" normalizeH="0" baseline="0" noProof="0" dirty="0">
               <a:ln>
@@ -20908,7 +20972,7 @@
 </p:sld>
 </file>
 
-<file path=ppt/slides/slide48.xml><?xml version="1.0" encoding="utf-8"?>
+<file path=ppt/slides/slide49.xml><?xml version="1.0" encoding="utf-8"?>
 <p:sld xmlns:a="http://schemas.openxmlformats.org/drawingml/2006/main" xmlns:r="http://schemas.openxmlformats.org/officeDocument/2006/relationships" xmlns:p="http://schemas.openxmlformats.org/presentationml/2006/main">
   <p:cSld>
     <p:spTree>
@@ -21167,7 +21231,7 @@
                 <a:tabLst/>
                 <a:defRPr/>
               </a:pPr>
-              <a:t>48</a:t>
+              <a:t>49</a:t>
             </a:fld>
             <a:endParaRPr kumimoji="0" lang="en-US" altLang="en-US" sz="1200" b="0" i="0" u="none" strike="noStrike" kern="1200" cap="none" spc="0" normalizeH="0" baseline="0" noProof="0">
               <a:ln>
@@ -21190,397 +21254,6 @@
     <p:extLst>
       <p:ext uri="{BB962C8B-B14F-4D97-AF65-F5344CB8AC3E}">
         <p14:creationId xmlns:p14="http://schemas.microsoft.com/office/powerpoint/2010/main" val="881040484"/>
-      </p:ext>
-    </p:extLst>
-  </p:cSld>
-  <p:clrMapOvr>
-    <a:masterClrMapping/>
-  </p:clrMapOvr>
-</p:sld>
-</file>
-
-<file path=ppt/slides/slide49.xml><?xml version="1.0" encoding="utf-8"?>
-<p:sld xmlns:a="http://schemas.openxmlformats.org/drawingml/2006/main" xmlns:r="http://schemas.openxmlformats.org/officeDocument/2006/relationships" xmlns:p="http://schemas.openxmlformats.org/presentationml/2006/main">
-  <p:cSld>
-    <p:spTree>
-      <p:nvGrpSpPr>
-        <p:cNvPr id="1" name=""/>
-        <p:cNvGrpSpPr/>
-        <p:nvPr/>
-      </p:nvGrpSpPr>
-      <p:grpSpPr>
-        <a:xfrm>
-          <a:off x="0" y="0"/>
-          <a:ext cx="0" cy="0"/>
-          <a:chOff x="0" y="0"/>
-          <a:chExt cx="0" cy="0"/>
-        </a:xfrm>
-      </p:grpSpPr>
-      <p:sp>
-        <p:nvSpPr>
-          <p:cNvPr id="2" name="Title 1"/>
-          <p:cNvSpPr>
-            <a:spLocks noGrp="1"/>
-          </p:cNvSpPr>
-          <p:nvPr>
-            <p:ph type="title"/>
-          </p:nvPr>
-        </p:nvSpPr>
-        <p:spPr>
-          <a:xfrm>
-            <a:off x="936516" y="1170297"/>
-            <a:ext cx="10417284" cy="723239"/>
-          </a:xfrm>
-        </p:spPr>
-        <p:txBody>
-          <a:bodyPr>
-            <a:normAutofit/>
-          </a:bodyPr>
-          <a:lstStyle/>
-          <a:p>
-            <a:r>
-              <a:rPr lang="en-US" dirty="0"/>
-              <a:t>Graphics2D</a:t>
-            </a:r>
-          </a:p>
-        </p:txBody>
-      </p:sp>
-      <p:sp>
-        <p:nvSpPr>
-          <p:cNvPr id="4" name="Footer Placeholder 3"/>
-          <p:cNvSpPr>
-            <a:spLocks noGrp="1"/>
-          </p:cNvSpPr>
-          <p:nvPr>
-            <p:ph type="ftr" sz="quarter" idx="11"/>
-          </p:nvPr>
-        </p:nvSpPr>
-        <p:spPr/>
-        <p:txBody>
-          <a:bodyPr/>
-          <a:lstStyle/>
-          <a:p>
-            <a:pPr marL="0" marR="0" lvl="0" indent="0" algn="l" defTabSz="914400" rtl="0" eaLnBrk="1" fontAlgn="auto" latinLnBrk="0" hangingPunct="1">
-              <a:lnSpc>
-                <a:spcPct val="100000"/>
-              </a:lnSpc>
-              <a:spcBef>
-                <a:spcPts val="0"/>
-              </a:spcBef>
-              <a:spcAft>
-                <a:spcPts val="0"/>
-              </a:spcAft>
-              <a:buClrTx/>
-              <a:buSzTx/>
-              <a:buFontTx/>
-              <a:buNone/>
-              <a:tabLst/>
-              <a:defRPr/>
-            </a:pPr>
-            <a:r>
-              <a:rPr kumimoji="0" lang="en-US" sz="1800" b="0" i="0" u="none" strike="noStrike" kern="1200" cap="none" spc="0" normalizeH="0" baseline="0" noProof="0" dirty="0">
-                <a:ln>
-                  <a:noFill/>
-                </a:ln>
-                <a:solidFill>
-                  <a:srgbClr val="000000"/>
-                </a:solidFill>
-                <a:effectLst/>
-                <a:uLnTx/>
-                <a:uFillTx/>
-                <a:latin typeface="Arial" panose="020B0604020202020204"/>
-                <a:ea typeface="+mn-ea"/>
-                <a:cs typeface="+mn-cs"/>
-              </a:rPr>
-              <a:t> </a:t>
-            </a:r>
-          </a:p>
-        </p:txBody>
-      </p:sp>
-      <p:sp>
-        <p:nvSpPr>
-          <p:cNvPr id="5" name="Slide Number Placeholder 4"/>
-          <p:cNvSpPr>
-            <a:spLocks noGrp="1"/>
-          </p:cNvSpPr>
-          <p:nvPr>
-            <p:ph type="sldNum" sz="quarter" idx="12"/>
-          </p:nvPr>
-        </p:nvSpPr>
-        <p:spPr/>
-        <p:txBody>
-          <a:bodyPr/>
-          <a:lstStyle/>
-          <a:p>
-            <a:pPr marL="0" marR="0" lvl="0" indent="0" algn="l" defTabSz="914400" rtl="0" eaLnBrk="1" fontAlgn="auto" latinLnBrk="0" hangingPunct="1">
-              <a:lnSpc>
-                <a:spcPct val="100000"/>
-              </a:lnSpc>
-              <a:spcBef>
-                <a:spcPts val="0"/>
-              </a:spcBef>
-              <a:spcAft>
-                <a:spcPts val="0"/>
-              </a:spcAft>
-              <a:buClrTx/>
-              <a:buSzTx/>
-              <a:buFontTx/>
-              <a:buNone/>
-              <a:tabLst/>
-              <a:defRPr/>
-            </a:pPr>
-            <a:fld id="{4FBCB832-F407-431A-BE08-B640AFF97906}" type="slidenum">
-              <a:rPr kumimoji="0" lang="en-US" sz="1800" b="0" i="0" u="none" strike="noStrike" kern="1200" cap="none" spc="0" normalizeH="0" baseline="0" noProof="0" smtClean="0">
-                <a:ln>
-                  <a:noFill/>
-                </a:ln>
-                <a:solidFill>
-                  <a:srgbClr val="000000"/>
-                </a:solidFill>
-                <a:effectLst/>
-                <a:uLnTx/>
-                <a:uFillTx/>
-                <a:latin typeface="Arial" panose="020B0604020202020204"/>
-                <a:ea typeface="+mn-ea"/>
-                <a:cs typeface="+mn-cs"/>
-              </a:rPr>
-              <a:pPr marL="0" marR="0" lvl="0" indent="0" algn="l" defTabSz="914400" rtl="0" eaLnBrk="1" fontAlgn="auto" latinLnBrk="0" hangingPunct="1">
-                <a:lnSpc>
-                  <a:spcPct val="100000"/>
-                </a:lnSpc>
-                <a:spcBef>
-                  <a:spcPts val="0"/>
-                </a:spcBef>
-                <a:spcAft>
-                  <a:spcPts val="0"/>
-                </a:spcAft>
-                <a:buClrTx/>
-                <a:buSzTx/>
-                <a:buFontTx/>
-                <a:buNone/>
-                <a:tabLst/>
-                <a:defRPr/>
-              </a:pPr>
-              <a:t>49</a:t>
-            </a:fld>
-            <a:endParaRPr kumimoji="0" lang="en-US" sz="1800" b="0" i="0" u="none" strike="noStrike" kern="1200" cap="none" spc="0" normalizeH="0" baseline="0" noProof="0" dirty="0">
-              <a:ln>
-                <a:noFill/>
-              </a:ln>
-              <a:solidFill>
-                <a:srgbClr val="000000"/>
-              </a:solidFill>
-              <a:effectLst/>
-              <a:uLnTx/>
-              <a:uFillTx/>
-              <a:latin typeface="Arial" panose="020B0604020202020204"/>
-              <a:ea typeface="+mn-ea"/>
-              <a:cs typeface="+mn-cs"/>
-            </a:endParaRPr>
-          </a:p>
-        </p:txBody>
-      </p:sp>
-      <p:sp>
-        <p:nvSpPr>
-          <p:cNvPr id="10" name="TextBox 9"/>
-          <p:cNvSpPr txBox="1"/>
-          <p:nvPr/>
-        </p:nvSpPr>
-        <p:spPr>
-          <a:xfrm>
-            <a:off x="936516" y="2146989"/>
-            <a:ext cx="3704860" cy="1477328"/>
-          </a:xfrm>
-          <a:prstGeom prst="rect">
-            <a:avLst/>
-          </a:prstGeom>
-          <a:noFill/>
-        </p:spPr>
-        <p:txBody>
-          <a:bodyPr wrap="none" rtlCol="0">
-            <a:spAutoFit/>
-          </a:bodyPr>
-          <a:lstStyle/>
-          <a:p>
-            <a:pPr marL="0" marR="0" lvl="0" indent="0" algn="l" defTabSz="914400" rtl="0" eaLnBrk="1" fontAlgn="auto" latinLnBrk="0" hangingPunct="1">
-              <a:lnSpc>
-                <a:spcPct val="100000"/>
-              </a:lnSpc>
-              <a:spcBef>
-                <a:spcPts val="0"/>
-              </a:spcBef>
-              <a:spcAft>
-                <a:spcPts val="0"/>
-              </a:spcAft>
-              <a:buClrTx/>
-              <a:buSzTx/>
-              <a:buFontTx/>
-              <a:buNone/>
-              <a:tabLst/>
-              <a:defRPr/>
-            </a:pPr>
-            <a:r>
-              <a:rPr kumimoji="0" lang="en-US" sz="1800" b="1" i="0" u="none" strike="noStrike" kern="1200" cap="none" spc="0" normalizeH="0" baseline="0" noProof="0" dirty="0">
-                <a:ln>
-                  <a:noFill/>
-                </a:ln>
-                <a:solidFill>
-                  <a:srgbClr val="000000"/>
-                </a:solidFill>
-                <a:effectLst/>
-                <a:uLnTx/>
-                <a:uFillTx/>
-                <a:latin typeface="Arial" panose="020B0604020202020204"/>
-                <a:ea typeface="+mn-ea"/>
-                <a:cs typeface="+mn-cs"/>
-              </a:rPr>
-              <a:t>Why?</a:t>
-            </a:r>
-          </a:p>
-          <a:p>
-            <a:pPr marL="285750" marR="0" lvl="0" indent="-285750" algn="l" defTabSz="914400" rtl="0" eaLnBrk="1" fontAlgn="auto" latinLnBrk="0" hangingPunct="1">
-              <a:lnSpc>
-                <a:spcPct val="100000"/>
-              </a:lnSpc>
-              <a:spcBef>
-                <a:spcPts val="0"/>
-              </a:spcBef>
-              <a:spcAft>
-                <a:spcPts val="0"/>
-              </a:spcAft>
-              <a:buClrTx/>
-              <a:buSzTx/>
-              <a:buFont typeface="Arial" panose="020B0604020202020204" pitchFamily="34" charset="0"/>
-              <a:buChar char="•"/>
-              <a:tabLst/>
-              <a:defRPr/>
-            </a:pPr>
-            <a:endParaRPr kumimoji="0" lang="en-US" sz="1800" b="0" i="0" u="none" strike="noStrike" kern="1200" cap="none" spc="0" normalizeH="0" baseline="0" noProof="0" dirty="0">
-              <a:ln>
-                <a:noFill/>
-              </a:ln>
-              <a:solidFill>
-                <a:srgbClr val="000000"/>
-              </a:solidFill>
-              <a:effectLst/>
-              <a:uLnTx/>
-              <a:uFillTx/>
-              <a:latin typeface="Arial" panose="020B0604020202020204"/>
-              <a:ea typeface="+mn-ea"/>
-              <a:cs typeface="+mn-cs"/>
-            </a:endParaRPr>
-          </a:p>
-          <a:p>
-            <a:pPr marL="285750" marR="0" lvl="0" indent="-285750" algn="l" defTabSz="914400" rtl="0" eaLnBrk="1" fontAlgn="auto" latinLnBrk="0" hangingPunct="1">
-              <a:lnSpc>
-                <a:spcPct val="100000"/>
-              </a:lnSpc>
-              <a:spcBef>
-                <a:spcPts val="0"/>
-              </a:spcBef>
-              <a:spcAft>
-                <a:spcPts val="0"/>
-              </a:spcAft>
-              <a:buClrTx/>
-              <a:buSzTx/>
-              <a:buFont typeface="Arial" panose="020B0604020202020204" pitchFamily="34" charset="0"/>
-              <a:buChar char="•"/>
-              <a:tabLst/>
-              <a:defRPr/>
-            </a:pPr>
-            <a:r>
-              <a:rPr kumimoji="0" lang="en-US" sz="1800" b="0" i="0" u="none" strike="noStrike" kern="1200" cap="none" spc="0" normalizeH="0" baseline="0" noProof="0" dirty="0">
-                <a:ln>
-                  <a:noFill/>
-                </a:ln>
-                <a:solidFill>
-                  <a:srgbClr val="000000"/>
-                </a:solidFill>
-                <a:effectLst/>
-                <a:uLnTx/>
-                <a:uFillTx/>
-                <a:latin typeface="Arial" panose="020B0604020202020204"/>
-                <a:ea typeface="+mn-ea"/>
-                <a:cs typeface="+mn-cs"/>
-              </a:rPr>
-              <a:t>Graphics2D has more functions</a:t>
-            </a:r>
-          </a:p>
-          <a:p>
-            <a:pPr marL="285750" marR="0" lvl="0" indent="-285750" algn="l" defTabSz="914400" rtl="0" eaLnBrk="1" fontAlgn="auto" latinLnBrk="0" hangingPunct="1">
-              <a:lnSpc>
-                <a:spcPct val="100000"/>
-              </a:lnSpc>
-              <a:spcBef>
-                <a:spcPts val="0"/>
-              </a:spcBef>
-              <a:spcAft>
-                <a:spcPts val="0"/>
-              </a:spcAft>
-              <a:buClrTx/>
-              <a:buSzTx/>
-              <a:buFont typeface="Arial" panose="020B0604020202020204" pitchFamily="34" charset="0"/>
-              <a:buChar char="•"/>
-              <a:tabLst/>
-              <a:defRPr/>
-            </a:pPr>
-            <a:endParaRPr kumimoji="0" lang="en-US" sz="1800" b="0" i="0" u="none" strike="noStrike" kern="1200" cap="none" spc="0" normalizeH="0" baseline="0" noProof="0" dirty="0">
-              <a:ln>
-                <a:noFill/>
-              </a:ln>
-              <a:solidFill>
-                <a:srgbClr val="000000"/>
-              </a:solidFill>
-              <a:effectLst/>
-              <a:uLnTx/>
-              <a:uFillTx/>
-              <a:latin typeface="Arial" panose="020B0604020202020204"/>
-              <a:ea typeface="+mn-ea"/>
-              <a:cs typeface="+mn-cs"/>
-            </a:endParaRPr>
-          </a:p>
-          <a:p>
-            <a:pPr marL="285750" marR="0" lvl="0" indent="-285750" algn="l" defTabSz="914400" rtl="0" eaLnBrk="1" fontAlgn="auto" latinLnBrk="0" hangingPunct="1">
-              <a:lnSpc>
-                <a:spcPct val="100000"/>
-              </a:lnSpc>
-              <a:spcBef>
-                <a:spcPts val="0"/>
-              </a:spcBef>
-              <a:spcAft>
-                <a:spcPts val="0"/>
-              </a:spcAft>
-              <a:buClrTx/>
-              <a:buSzTx/>
-              <a:buFont typeface="Arial" panose="020B0604020202020204" pitchFamily="34" charset="0"/>
-              <a:buChar char="•"/>
-              <a:tabLst/>
-              <a:defRPr/>
-            </a:pPr>
-            <a:r>
-              <a:rPr kumimoji="0" lang="en-US" sz="1800" b="0" i="0" u="none" strike="noStrike" kern="1200" cap="none" spc="0" normalizeH="0" baseline="0" noProof="0" dirty="0">
-                <a:ln>
-                  <a:noFill/>
-                </a:ln>
-                <a:solidFill>
-                  <a:srgbClr val="000000"/>
-                </a:solidFill>
-                <a:effectLst/>
-                <a:uLnTx/>
-                <a:uFillTx/>
-                <a:latin typeface="Arial" panose="020B0604020202020204"/>
-                <a:ea typeface="+mn-ea"/>
-                <a:cs typeface="+mn-cs"/>
-              </a:rPr>
-              <a:t>Graphics2D is still AWT</a:t>
-            </a:r>
-          </a:p>
-        </p:txBody>
-      </p:sp>
-    </p:spTree>
-    <p:extLst>
-      <p:ext uri="{BB962C8B-B14F-4D97-AF65-F5344CB8AC3E}">
-        <p14:creationId xmlns:p14="http://schemas.microsoft.com/office/powerpoint/2010/main" val="2175131094"/>
       </p:ext>
     </p:extLst>
   </p:cSld>
@@ -22030,7 +21703,7 @@
           <a:p>
             <a:r>
               <a:rPr lang="en-US" dirty="0"/>
-              <a:t>Simple Graphics2D example</a:t>
+              <a:t>Graphics2D</a:t>
             </a:r>
           </a:p>
         </p:txBody>
@@ -22152,6 +21825,397 @@
                 <a:defRPr/>
               </a:pPr>
               <a:t>50</a:t>
+            </a:fld>
+            <a:endParaRPr kumimoji="0" lang="en-US" sz="1800" b="0" i="0" u="none" strike="noStrike" kern="1200" cap="none" spc="0" normalizeH="0" baseline="0" noProof="0" dirty="0">
+              <a:ln>
+                <a:noFill/>
+              </a:ln>
+              <a:solidFill>
+                <a:srgbClr val="000000"/>
+              </a:solidFill>
+              <a:effectLst/>
+              <a:uLnTx/>
+              <a:uFillTx/>
+              <a:latin typeface="Arial" panose="020B0604020202020204"/>
+              <a:ea typeface="+mn-ea"/>
+              <a:cs typeface="+mn-cs"/>
+            </a:endParaRPr>
+          </a:p>
+        </p:txBody>
+      </p:sp>
+      <p:sp>
+        <p:nvSpPr>
+          <p:cNvPr id="10" name="TextBox 9"/>
+          <p:cNvSpPr txBox="1"/>
+          <p:nvPr/>
+        </p:nvSpPr>
+        <p:spPr>
+          <a:xfrm>
+            <a:off x="936516" y="2146989"/>
+            <a:ext cx="3704860" cy="1477328"/>
+          </a:xfrm>
+          <a:prstGeom prst="rect">
+            <a:avLst/>
+          </a:prstGeom>
+          <a:noFill/>
+        </p:spPr>
+        <p:txBody>
+          <a:bodyPr wrap="none" rtlCol="0">
+            <a:spAutoFit/>
+          </a:bodyPr>
+          <a:lstStyle/>
+          <a:p>
+            <a:pPr marL="0" marR="0" lvl="0" indent="0" algn="l" defTabSz="914400" rtl="0" eaLnBrk="1" fontAlgn="auto" latinLnBrk="0" hangingPunct="1">
+              <a:lnSpc>
+                <a:spcPct val="100000"/>
+              </a:lnSpc>
+              <a:spcBef>
+                <a:spcPts val="0"/>
+              </a:spcBef>
+              <a:spcAft>
+                <a:spcPts val="0"/>
+              </a:spcAft>
+              <a:buClrTx/>
+              <a:buSzTx/>
+              <a:buFontTx/>
+              <a:buNone/>
+              <a:tabLst/>
+              <a:defRPr/>
+            </a:pPr>
+            <a:r>
+              <a:rPr kumimoji="0" lang="en-US" sz="1800" b="1" i="0" u="none" strike="noStrike" kern="1200" cap="none" spc="0" normalizeH="0" baseline="0" noProof="0" dirty="0">
+                <a:ln>
+                  <a:noFill/>
+                </a:ln>
+                <a:solidFill>
+                  <a:srgbClr val="000000"/>
+                </a:solidFill>
+                <a:effectLst/>
+                <a:uLnTx/>
+                <a:uFillTx/>
+                <a:latin typeface="Arial" panose="020B0604020202020204"/>
+                <a:ea typeface="+mn-ea"/>
+                <a:cs typeface="+mn-cs"/>
+              </a:rPr>
+              <a:t>Why?</a:t>
+            </a:r>
+          </a:p>
+          <a:p>
+            <a:pPr marL="285750" marR="0" lvl="0" indent="-285750" algn="l" defTabSz="914400" rtl="0" eaLnBrk="1" fontAlgn="auto" latinLnBrk="0" hangingPunct="1">
+              <a:lnSpc>
+                <a:spcPct val="100000"/>
+              </a:lnSpc>
+              <a:spcBef>
+                <a:spcPts val="0"/>
+              </a:spcBef>
+              <a:spcAft>
+                <a:spcPts val="0"/>
+              </a:spcAft>
+              <a:buClrTx/>
+              <a:buSzTx/>
+              <a:buFont typeface="Arial" panose="020B0604020202020204" pitchFamily="34" charset="0"/>
+              <a:buChar char="•"/>
+              <a:tabLst/>
+              <a:defRPr/>
+            </a:pPr>
+            <a:endParaRPr kumimoji="0" lang="en-US" sz="1800" b="0" i="0" u="none" strike="noStrike" kern="1200" cap="none" spc="0" normalizeH="0" baseline="0" noProof="0" dirty="0">
+              <a:ln>
+                <a:noFill/>
+              </a:ln>
+              <a:solidFill>
+                <a:srgbClr val="000000"/>
+              </a:solidFill>
+              <a:effectLst/>
+              <a:uLnTx/>
+              <a:uFillTx/>
+              <a:latin typeface="Arial" panose="020B0604020202020204"/>
+              <a:ea typeface="+mn-ea"/>
+              <a:cs typeface="+mn-cs"/>
+            </a:endParaRPr>
+          </a:p>
+          <a:p>
+            <a:pPr marL="285750" marR="0" lvl="0" indent="-285750" algn="l" defTabSz="914400" rtl="0" eaLnBrk="1" fontAlgn="auto" latinLnBrk="0" hangingPunct="1">
+              <a:lnSpc>
+                <a:spcPct val="100000"/>
+              </a:lnSpc>
+              <a:spcBef>
+                <a:spcPts val="0"/>
+              </a:spcBef>
+              <a:spcAft>
+                <a:spcPts val="0"/>
+              </a:spcAft>
+              <a:buClrTx/>
+              <a:buSzTx/>
+              <a:buFont typeface="Arial" panose="020B0604020202020204" pitchFamily="34" charset="0"/>
+              <a:buChar char="•"/>
+              <a:tabLst/>
+              <a:defRPr/>
+            </a:pPr>
+            <a:r>
+              <a:rPr kumimoji="0" lang="en-US" sz="1800" b="0" i="0" u="none" strike="noStrike" kern="1200" cap="none" spc="0" normalizeH="0" baseline="0" noProof="0" dirty="0">
+                <a:ln>
+                  <a:noFill/>
+                </a:ln>
+                <a:solidFill>
+                  <a:srgbClr val="000000"/>
+                </a:solidFill>
+                <a:effectLst/>
+                <a:uLnTx/>
+                <a:uFillTx/>
+                <a:latin typeface="Arial" panose="020B0604020202020204"/>
+                <a:ea typeface="+mn-ea"/>
+                <a:cs typeface="+mn-cs"/>
+              </a:rPr>
+              <a:t>Graphics2D has more functions</a:t>
+            </a:r>
+          </a:p>
+          <a:p>
+            <a:pPr marL="285750" marR="0" lvl="0" indent="-285750" algn="l" defTabSz="914400" rtl="0" eaLnBrk="1" fontAlgn="auto" latinLnBrk="0" hangingPunct="1">
+              <a:lnSpc>
+                <a:spcPct val="100000"/>
+              </a:lnSpc>
+              <a:spcBef>
+                <a:spcPts val="0"/>
+              </a:spcBef>
+              <a:spcAft>
+                <a:spcPts val="0"/>
+              </a:spcAft>
+              <a:buClrTx/>
+              <a:buSzTx/>
+              <a:buFont typeface="Arial" panose="020B0604020202020204" pitchFamily="34" charset="0"/>
+              <a:buChar char="•"/>
+              <a:tabLst/>
+              <a:defRPr/>
+            </a:pPr>
+            <a:endParaRPr kumimoji="0" lang="en-US" sz="1800" b="0" i="0" u="none" strike="noStrike" kern="1200" cap="none" spc="0" normalizeH="0" baseline="0" noProof="0" dirty="0">
+              <a:ln>
+                <a:noFill/>
+              </a:ln>
+              <a:solidFill>
+                <a:srgbClr val="000000"/>
+              </a:solidFill>
+              <a:effectLst/>
+              <a:uLnTx/>
+              <a:uFillTx/>
+              <a:latin typeface="Arial" panose="020B0604020202020204"/>
+              <a:ea typeface="+mn-ea"/>
+              <a:cs typeface="+mn-cs"/>
+            </a:endParaRPr>
+          </a:p>
+          <a:p>
+            <a:pPr marL="285750" marR="0" lvl="0" indent="-285750" algn="l" defTabSz="914400" rtl="0" eaLnBrk="1" fontAlgn="auto" latinLnBrk="0" hangingPunct="1">
+              <a:lnSpc>
+                <a:spcPct val="100000"/>
+              </a:lnSpc>
+              <a:spcBef>
+                <a:spcPts val="0"/>
+              </a:spcBef>
+              <a:spcAft>
+                <a:spcPts val="0"/>
+              </a:spcAft>
+              <a:buClrTx/>
+              <a:buSzTx/>
+              <a:buFont typeface="Arial" panose="020B0604020202020204" pitchFamily="34" charset="0"/>
+              <a:buChar char="•"/>
+              <a:tabLst/>
+              <a:defRPr/>
+            </a:pPr>
+            <a:r>
+              <a:rPr kumimoji="0" lang="en-US" sz="1800" b="0" i="0" u="none" strike="noStrike" kern="1200" cap="none" spc="0" normalizeH="0" baseline="0" noProof="0" dirty="0">
+                <a:ln>
+                  <a:noFill/>
+                </a:ln>
+                <a:solidFill>
+                  <a:srgbClr val="000000"/>
+                </a:solidFill>
+                <a:effectLst/>
+                <a:uLnTx/>
+                <a:uFillTx/>
+                <a:latin typeface="Arial" panose="020B0604020202020204"/>
+                <a:ea typeface="+mn-ea"/>
+                <a:cs typeface="+mn-cs"/>
+              </a:rPr>
+              <a:t>Graphics2D is still AWT</a:t>
+            </a:r>
+          </a:p>
+        </p:txBody>
+      </p:sp>
+    </p:spTree>
+    <p:extLst>
+      <p:ext uri="{BB962C8B-B14F-4D97-AF65-F5344CB8AC3E}">
+        <p14:creationId xmlns:p14="http://schemas.microsoft.com/office/powerpoint/2010/main" val="2175131094"/>
+      </p:ext>
+    </p:extLst>
+  </p:cSld>
+  <p:clrMapOvr>
+    <a:masterClrMapping/>
+  </p:clrMapOvr>
+</p:sld>
+</file>
+
+<file path=ppt/slides/slide51.xml><?xml version="1.0" encoding="utf-8"?>
+<p:sld xmlns:a="http://schemas.openxmlformats.org/drawingml/2006/main" xmlns:r="http://schemas.openxmlformats.org/officeDocument/2006/relationships" xmlns:p="http://schemas.openxmlformats.org/presentationml/2006/main">
+  <p:cSld>
+    <p:spTree>
+      <p:nvGrpSpPr>
+        <p:cNvPr id="1" name=""/>
+        <p:cNvGrpSpPr/>
+        <p:nvPr/>
+      </p:nvGrpSpPr>
+      <p:grpSpPr>
+        <a:xfrm>
+          <a:off x="0" y="0"/>
+          <a:ext cx="0" cy="0"/>
+          <a:chOff x="0" y="0"/>
+          <a:chExt cx="0" cy="0"/>
+        </a:xfrm>
+      </p:grpSpPr>
+      <p:sp>
+        <p:nvSpPr>
+          <p:cNvPr id="2" name="Title 1"/>
+          <p:cNvSpPr>
+            <a:spLocks noGrp="1"/>
+          </p:cNvSpPr>
+          <p:nvPr>
+            <p:ph type="title"/>
+          </p:nvPr>
+        </p:nvSpPr>
+        <p:spPr>
+          <a:xfrm>
+            <a:off x="936516" y="1170297"/>
+            <a:ext cx="10417284" cy="723239"/>
+          </a:xfrm>
+        </p:spPr>
+        <p:txBody>
+          <a:bodyPr>
+            <a:normAutofit/>
+          </a:bodyPr>
+          <a:lstStyle/>
+          <a:p>
+            <a:r>
+              <a:rPr lang="en-US" dirty="0"/>
+              <a:t>Simple Graphics2D example</a:t>
+            </a:r>
+          </a:p>
+        </p:txBody>
+      </p:sp>
+      <p:sp>
+        <p:nvSpPr>
+          <p:cNvPr id="4" name="Footer Placeholder 3"/>
+          <p:cNvSpPr>
+            <a:spLocks noGrp="1"/>
+          </p:cNvSpPr>
+          <p:nvPr>
+            <p:ph type="ftr" sz="quarter" idx="11"/>
+          </p:nvPr>
+        </p:nvSpPr>
+        <p:spPr/>
+        <p:txBody>
+          <a:bodyPr/>
+          <a:lstStyle/>
+          <a:p>
+            <a:pPr marL="0" marR="0" lvl="0" indent="0" algn="l" defTabSz="914400" rtl="0" eaLnBrk="1" fontAlgn="auto" latinLnBrk="0" hangingPunct="1">
+              <a:lnSpc>
+                <a:spcPct val="100000"/>
+              </a:lnSpc>
+              <a:spcBef>
+                <a:spcPts val="0"/>
+              </a:spcBef>
+              <a:spcAft>
+                <a:spcPts val="0"/>
+              </a:spcAft>
+              <a:buClrTx/>
+              <a:buSzTx/>
+              <a:buFontTx/>
+              <a:buNone/>
+              <a:tabLst/>
+              <a:defRPr/>
+            </a:pPr>
+            <a:r>
+              <a:rPr kumimoji="0" lang="en-US" sz="1800" b="0" i="0" u="none" strike="noStrike" kern="1200" cap="none" spc="0" normalizeH="0" baseline="0" noProof="0" dirty="0">
+                <a:ln>
+                  <a:noFill/>
+                </a:ln>
+                <a:solidFill>
+                  <a:srgbClr val="000000"/>
+                </a:solidFill>
+                <a:effectLst/>
+                <a:uLnTx/>
+                <a:uFillTx/>
+                <a:latin typeface="Arial" panose="020B0604020202020204"/>
+                <a:ea typeface="+mn-ea"/>
+                <a:cs typeface="+mn-cs"/>
+              </a:rPr>
+              <a:t> </a:t>
+            </a:r>
+          </a:p>
+        </p:txBody>
+      </p:sp>
+      <p:sp>
+        <p:nvSpPr>
+          <p:cNvPr id="5" name="Slide Number Placeholder 4"/>
+          <p:cNvSpPr>
+            <a:spLocks noGrp="1"/>
+          </p:cNvSpPr>
+          <p:nvPr>
+            <p:ph type="sldNum" sz="quarter" idx="12"/>
+          </p:nvPr>
+        </p:nvSpPr>
+        <p:spPr/>
+        <p:txBody>
+          <a:bodyPr/>
+          <a:lstStyle/>
+          <a:p>
+            <a:pPr marL="0" marR="0" lvl="0" indent="0" algn="l" defTabSz="914400" rtl="0" eaLnBrk="1" fontAlgn="auto" latinLnBrk="0" hangingPunct="1">
+              <a:lnSpc>
+                <a:spcPct val="100000"/>
+              </a:lnSpc>
+              <a:spcBef>
+                <a:spcPts val="0"/>
+              </a:spcBef>
+              <a:spcAft>
+                <a:spcPts val="0"/>
+              </a:spcAft>
+              <a:buClrTx/>
+              <a:buSzTx/>
+              <a:buFontTx/>
+              <a:buNone/>
+              <a:tabLst/>
+              <a:defRPr/>
+            </a:pPr>
+            <a:fld id="{4FBCB832-F407-431A-BE08-B640AFF97906}" type="slidenum">
+              <a:rPr kumimoji="0" lang="en-US" sz="1800" b="0" i="0" u="none" strike="noStrike" kern="1200" cap="none" spc="0" normalizeH="0" baseline="0" noProof="0" smtClean="0">
+                <a:ln>
+                  <a:noFill/>
+                </a:ln>
+                <a:solidFill>
+                  <a:srgbClr val="000000"/>
+                </a:solidFill>
+                <a:effectLst/>
+                <a:uLnTx/>
+                <a:uFillTx/>
+                <a:latin typeface="Arial" panose="020B0604020202020204"/>
+                <a:ea typeface="+mn-ea"/>
+                <a:cs typeface="+mn-cs"/>
+              </a:rPr>
+              <a:pPr marL="0" marR="0" lvl="0" indent="0" algn="l" defTabSz="914400" rtl="0" eaLnBrk="1" fontAlgn="auto" latinLnBrk="0" hangingPunct="1">
+                <a:lnSpc>
+                  <a:spcPct val="100000"/>
+                </a:lnSpc>
+                <a:spcBef>
+                  <a:spcPts val="0"/>
+                </a:spcBef>
+                <a:spcAft>
+                  <a:spcPts val="0"/>
+                </a:spcAft>
+                <a:buClrTx/>
+                <a:buSzTx/>
+                <a:buFontTx/>
+                <a:buNone/>
+                <a:tabLst/>
+                <a:defRPr/>
+              </a:pPr>
+              <a:t>51</a:t>
             </a:fld>
             <a:endParaRPr kumimoji="0" lang="en-US" sz="1800" b="0" i="0" u="none" strike="noStrike" kern="1200" cap="none" spc="0" normalizeH="0" baseline="0" noProof="0" dirty="0">
               <a:ln>
@@ -22529,7 +22593,7 @@
 </p:sld>
 </file>
 
-<file path=ppt/slides/slide51.xml><?xml version="1.0" encoding="utf-8"?>
+<file path=ppt/slides/slide52.xml><?xml version="1.0" encoding="utf-8"?>
 <p:sld xmlns:a="http://schemas.openxmlformats.org/drawingml/2006/main" xmlns:r="http://schemas.openxmlformats.org/officeDocument/2006/relationships" xmlns:p="http://schemas.openxmlformats.org/presentationml/2006/main">
   <p:cSld>
     <p:spTree>
@@ -22691,7 +22755,7 @@
                 <a:tabLst/>
                 <a:defRPr/>
               </a:pPr>
-              <a:t>51</a:t>
+              <a:t>52</a:t>
             </a:fld>
             <a:endParaRPr kumimoji="0" lang="en-US" sz="1800" b="0" i="0" u="none" strike="noStrike" kern="1200" cap="none" spc="0" normalizeH="0" baseline="0" noProof="0" dirty="0">
               <a:ln>
@@ -22747,7 +22811,7 @@
 </p:sld>
 </file>
 
-<file path=ppt/slides/slide52.xml><?xml version="1.0" encoding="utf-8"?>
+<file path=ppt/slides/slide53.xml><?xml version="1.0" encoding="utf-8"?>
 <p:sld xmlns:a="http://schemas.openxmlformats.org/drawingml/2006/main" xmlns:r="http://schemas.openxmlformats.org/officeDocument/2006/relationships" xmlns:p="http://schemas.openxmlformats.org/presentationml/2006/main">
   <p:cSld>
     <p:spTree>
@@ -23006,7 +23070,7 @@
                 <a:tabLst/>
                 <a:defRPr/>
               </a:pPr>
-              <a:t>52</a:t>
+              <a:t>53</a:t>
             </a:fld>
             <a:endParaRPr kumimoji="0" lang="en-US" altLang="en-US" sz="1200" b="0" i="0" u="none" strike="noStrike" kern="1200" cap="none" spc="0" normalizeH="0" baseline="0" noProof="0">
               <a:ln>
@@ -23038,7 +23102,7 @@
 </p:sld>
 </file>
 
-<file path=ppt/slides/slide53.xml><?xml version="1.0" encoding="utf-8"?>
+<file path=ppt/slides/slide54.xml><?xml version="1.0" encoding="utf-8"?>
 <p:sld xmlns:a="http://schemas.openxmlformats.org/drawingml/2006/main" xmlns:r="http://schemas.openxmlformats.org/officeDocument/2006/relationships" xmlns:p="http://schemas.openxmlformats.org/presentationml/2006/main">
   <p:cSld>
     <p:spTree>
@@ -23200,7 +23264,7 @@
                 <a:tabLst/>
                 <a:defRPr/>
               </a:pPr>
-              <a:t>53</a:t>
+              <a:t>54</a:t>
             </a:fld>
             <a:endParaRPr kumimoji="0" lang="en-US" sz="1800" b="0" i="0" u="none" strike="noStrike" kern="1200" cap="none" spc="0" normalizeH="0" baseline="0" noProof="0" dirty="0">
               <a:ln>
@@ -23425,7 +23489,7 @@
 </p:sld>
 </file>
 
-<file path=ppt/slides/slide54.xml><?xml version="1.0" encoding="utf-8"?>
+<file path=ppt/slides/slide55.xml><?xml version="1.0" encoding="utf-8"?>
 <p:sld xmlns:a="http://schemas.openxmlformats.org/drawingml/2006/main" xmlns:r="http://schemas.openxmlformats.org/officeDocument/2006/relationships" xmlns:p="http://schemas.openxmlformats.org/presentationml/2006/main">
   <p:cSld>
     <p:spTree>
@@ -23587,7 +23651,7 @@
                 <a:tabLst/>
                 <a:defRPr/>
               </a:pPr>
-              <a:t>54</a:t>
+              <a:t>55</a:t>
             </a:fld>
             <a:endParaRPr kumimoji="0" lang="en-US" sz="1800" b="0" i="0" u="none" strike="noStrike" kern="1200" cap="none" spc="0" normalizeH="0" baseline="0" noProof="0" dirty="0">
               <a:ln>
@@ -23802,7 +23866,7 @@
 </p:sld>
 </file>
 
-<file path=ppt/slides/slide55.xml><?xml version="1.0" encoding="utf-8"?>
+<file path=ppt/slides/slide56.xml><?xml version="1.0" encoding="utf-8"?>
 <p:sld xmlns:a="http://schemas.openxmlformats.org/drawingml/2006/main" xmlns:r="http://schemas.openxmlformats.org/officeDocument/2006/relationships" xmlns:p="http://schemas.openxmlformats.org/presentationml/2006/main">
   <p:cSld>
     <p:spTree>
@@ -24061,7 +24125,7 @@
                 <a:tabLst/>
                 <a:defRPr/>
               </a:pPr>
-              <a:t>55</a:t>
+              <a:t>56</a:t>
             </a:fld>
             <a:endParaRPr kumimoji="0" lang="en-US" altLang="en-US" sz="1200" b="0" i="0" u="none" strike="noStrike" kern="1200" cap="none" spc="0" normalizeH="0" baseline="0" noProof="0">
               <a:ln>
@@ -24093,7 +24157,7 @@
 </p:sld>
 </file>
 
-<file path=ppt/slides/slide56.xml><?xml version="1.0" encoding="utf-8"?>
+<file path=ppt/slides/slide57.xml><?xml version="1.0" encoding="utf-8"?>
 <p:sld xmlns:a="http://schemas.openxmlformats.org/drawingml/2006/main" xmlns:r="http://schemas.openxmlformats.org/officeDocument/2006/relationships" xmlns:p="http://schemas.openxmlformats.org/presentationml/2006/main">
   <p:cSld>
     <p:spTree>
@@ -24255,7 +24319,7 @@
                 <a:tabLst/>
                 <a:defRPr/>
               </a:pPr>
-              <a:t>56</a:t>
+              <a:t>57</a:t>
             </a:fld>
             <a:endParaRPr kumimoji="0" lang="en-US" sz="1800" b="0" i="0" u="none" strike="noStrike" kern="1200" cap="none" spc="0" normalizeH="0" baseline="0" noProof="0" dirty="0">
               <a:ln>
@@ -24480,7 +24544,7 @@
 </p:sld>
 </file>
 
-<file path=ppt/slides/slide57.xml><?xml version="1.0" encoding="utf-8"?>
+<file path=ppt/slides/slide58.xml><?xml version="1.0" encoding="utf-8"?>
 <p:sld xmlns:a="http://schemas.openxmlformats.org/drawingml/2006/main" xmlns:r="http://schemas.openxmlformats.org/officeDocument/2006/relationships" xmlns:p="http://schemas.openxmlformats.org/presentationml/2006/main">
   <p:cSld>
     <p:spTree>
@@ -24739,7 +24803,7 @@
                 <a:tabLst/>
                 <a:defRPr/>
               </a:pPr>
-              <a:t>57</a:t>
+              <a:t>58</a:t>
             </a:fld>
             <a:endParaRPr kumimoji="0" lang="en-US" altLang="en-US" sz="1200" b="0" i="0" u="none" strike="noStrike" kern="1200" cap="none" spc="0" normalizeH="0" baseline="0" noProof="0">
               <a:ln>
@@ -24771,7 +24835,7 @@
 </p:sld>
 </file>
 
-<file path=ppt/slides/slide58.xml><?xml version="1.0" encoding="utf-8"?>
+<file path=ppt/slides/slide59.xml><?xml version="1.0" encoding="utf-8"?>
 <p:sld xmlns:a="http://schemas.openxmlformats.org/drawingml/2006/main" xmlns:r="http://schemas.openxmlformats.org/officeDocument/2006/relationships" xmlns:p="http://schemas.openxmlformats.org/presentationml/2006/main">
   <p:cSld>
     <p:spTree>
@@ -24933,7 +24997,7 @@
                 <a:tabLst/>
                 <a:defRPr/>
               </a:pPr>
-              <a:t>58</a:t>
+              <a:t>59</a:t>
             </a:fld>
             <a:endParaRPr kumimoji="0" lang="en-US" sz="1800" b="0" i="0" u="none" strike="noStrike" kern="1200" cap="none" spc="0" normalizeH="0" baseline="0" noProof="0" dirty="0">
               <a:ln>
@@ -25013,7 +25077,363 @@
 </p:sld>
 </file>
 
-<file path=ppt/slides/slide59.xml><?xml version="1.0" encoding="utf-8"?>
+<file path=ppt/slides/slide6.xml><?xml version="1.0" encoding="utf-8"?>
+<p:sld xmlns:a="http://schemas.openxmlformats.org/drawingml/2006/main" xmlns:r="http://schemas.openxmlformats.org/officeDocument/2006/relationships" xmlns:p="http://schemas.openxmlformats.org/presentationml/2006/main">
+  <p:cSld>
+    <p:spTree>
+      <p:nvGrpSpPr>
+        <p:cNvPr id="1" name=""/>
+        <p:cNvGrpSpPr/>
+        <p:nvPr/>
+      </p:nvGrpSpPr>
+      <p:grpSpPr>
+        <a:xfrm>
+          <a:off x="0" y="0"/>
+          <a:ext cx="0" cy="0"/>
+          <a:chOff x="0" y="0"/>
+          <a:chExt cx="0" cy="0"/>
+        </a:xfrm>
+      </p:grpSpPr>
+      <p:sp>
+        <p:nvSpPr>
+          <p:cNvPr id="4098" name="Title 1"/>
+          <p:cNvSpPr>
+            <a:spLocks noGrp="1"/>
+          </p:cNvSpPr>
+          <p:nvPr>
+            <p:ph type="title"/>
+          </p:nvPr>
+        </p:nvSpPr>
+        <p:spPr>
+          <a:xfrm>
+            <a:off x="936516" y="1170297"/>
+            <a:ext cx="10417284" cy="593767"/>
+          </a:xfrm>
+          <a:ln>
+            <a:miter lim="800000"/>
+            <a:headEnd/>
+            <a:tailEnd/>
+          </a:ln>
+        </p:spPr>
+        <p:txBody>
+          <a:bodyPr/>
+          <a:lstStyle/>
+          <a:p>
+            <a:pPr eaLnBrk="1" hangingPunct="1"/>
+            <a:r>
+              <a:rPr lang="en-US" altLang="en-US" dirty="0"/>
+              <a:t>Graphical User Interfaces (GUI) with Swing</a:t>
+            </a:r>
+          </a:p>
+        </p:txBody>
+      </p:sp>
+      <p:sp>
+        <p:nvSpPr>
+          <p:cNvPr id="4099" name="Content Placeholder 2"/>
+          <p:cNvSpPr>
+            <a:spLocks noGrp="1"/>
+          </p:cNvSpPr>
+          <p:nvPr>
+            <p:ph idx="1"/>
+          </p:nvPr>
+        </p:nvSpPr>
+        <p:spPr>
+          <a:xfrm>
+            <a:off x="936516" y="2190440"/>
+            <a:ext cx="10417284" cy="3835800"/>
+          </a:xfrm>
+          <a:ln>
+            <a:miter lim="800000"/>
+            <a:headEnd/>
+            <a:tailEnd/>
+          </a:ln>
+        </p:spPr>
+        <p:txBody>
+          <a:bodyPr rtlCol="0">
+            <a:normAutofit/>
+          </a:bodyPr>
+          <a:lstStyle/>
+          <a:p>
+            <a:pPr>
+              <a:defRPr/>
+            </a:pPr>
+            <a:r>
+              <a:rPr lang="en-US" sz="2400" dirty="0"/>
+              <a:t>Swing is part of Oracle's Java Foundation Classes (JFC).</a:t>
+            </a:r>
+            <a:endParaRPr lang="en-US" sz="2400" i="1" dirty="0"/>
+          </a:p>
+          <a:p>
+            <a:pPr>
+              <a:defRPr/>
+            </a:pPr>
+            <a:r>
+              <a:rPr lang="en-US" sz="2400" i="1" dirty="0"/>
+              <a:t>You can also use the Standard Widget Toolkit (</a:t>
+            </a:r>
+            <a:r>
+              <a:rPr lang="en-US" sz="2400" i="1" dirty="0">
+                <a:solidFill>
+                  <a:srgbClr val="C00000"/>
+                </a:solidFill>
+              </a:rPr>
+              <a:t>SWT</a:t>
+            </a:r>
+            <a:r>
+              <a:rPr lang="en-US" sz="2400" i="1" dirty="0"/>
+              <a:t>) from Eclipse </a:t>
+            </a:r>
+          </a:p>
+          <a:p>
+            <a:pPr marL="0" indent="0">
+              <a:buNone/>
+              <a:defRPr/>
+            </a:pPr>
+            <a:endParaRPr lang="en-US" sz="2400" dirty="0"/>
+          </a:p>
+          <a:p>
+            <a:pPr marL="0" indent="0">
+              <a:buNone/>
+              <a:defRPr/>
+            </a:pPr>
+            <a:r>
+              <a:rPr lang="en-US" sz="2400" b="1" dirty="0"/>
+              <a:t>Before Swing: </a:t>
+            </a:r>
+            <a:endParaRPr lang="en-US" sz="2400" b="1" dirty="0">
+              <a:solidFill>
+                <a:srgbClr val="C00000"/>
+              </a:solidFill>
+            </a:endParaRPr>
+          </a:p>
+          <a:p>
+            <a:pPr>
+              <a:defRPr/>
+            </a:pPr>
+            <a:endParaRPr lang="en-US" sz="2400" dirty="0">
+              <a:solidFill>
+                <a:srgbClr val="C00000"/>
+              </a:solidFill>
+            </a:endParaRPr>
+          </a:p>
+          <a:p>
+            <a:pPr>
+              <a:defRPr/>
+            </a:pPr>
+            <a:r>
+              <a:rPr lang="en-US" sz="2400" dirty="0">
+                <a:solidFill>
+                  <a:srgbClr val="C00000"/>
+                </a:solidFill>
+              </a:rPr>
+              <a:t>Abstract Window Toolkit (AWT) </a:t>
+            </a:r>
+            <a:r>
+              <a:rPr lang="en-US" sz="2400" dirty="0"/>
+              <a:t>was the original. </a:t>
+            </a:r>
+          </a:p>
+          <a:p>
+            <a:pPr>
+              <a:defRPr/>
+            </a:pPr>
+            <a:endParaRPr lang="en-US" sz="2400" dirty="0"/>
+          </a:p>
+          <a:p>
+            <a:pPr>
+              <a:defRPr/>
+            </a:pPr>
+            <a:r>
+              <a:rPr lang="en-US" sz="2400" dirty="0"/>
+              <a:t>Limited set of GUI components, layout managers, events, etc.</a:t>
+            </a:r>
+          </a:p>
+          <a:p>
+            <a:pPr>
+              <a:defRPr/>
+            </a:pPr>
+            <a:endParaRPr lang="en-US" sz="2400" dirty="0"/>
+          </a:p>
+          <a:p>
+            <a:pPr>
+              <a:defRPr/>
+            </a:pPr>
+            <a:endParaRPr lang="en-US" sz="2000" dirty="0"/>
+          </a:p>
+        </p:txBody>
+      </p:sp>
+      <p:sp>
+        <p:nvSpPr>
+          <p:cNvPr id="4" name="Slide Number Placeholder 3"/>
+          <p:cNvSpPr>
+            <a:spLocks noGrp="1"/>
+          </p:cNvSpPr>
+          <p:nvPr>
+            <p:ph type="sldNum" sz="quarter" idx="10"/>
+          </p:nvPr>
+        </p:nvSpPr>
+        <p:spPr/>
+        <p:txBody>
+          <a:bodyPr/>
+          <a:lstStyle>
+            <a:lvl1pPr eaLnBrk="0" hangingPunct="0">
+              <a:defRPr>
+                <a:solidFill>
+                  <a:schemeClr val="tx1"/>
+                </a:solidFill>
+                <a:latin typeface="Calibri" panose="020F0502020204030204" pitchFamily="34" charset="0"/>
+                <a:cs typeface="Arial" panose="020B0604020202020204" pitchFamily="34" charset="0"/>
+              </a:defRPr>
+            </a:lvl1pPr>
+            <a:lvl2pPr marL="742950" indent="-285750" eaLnBrk="0" hangingPunct="0">
+              <a:defRPr>
+                <a:solidFill>
+                  <a:schemeClr val="tx1"/>
+                </a:solidFill>
+                <a:latin typeface="Calibri" panose="020F0502020204030204" pitchFamily="34" charset="0"/>
+                <a:cs typeface="Arial" panose="020B0604020202020204" pitchFamily="34" charset="0"/>
+              </a:defRPr>
+            </a:lvl2pPr>
+            <a:lvl3pPr marL="1143000" indent="-228600" eaLnBrk="0" hangingPunct="0">
+              <a:defRPr>
+                <a:solidFill>
+                  <a:schemeClr val="tx1"/>
+                </a:solidFill>
+                <a:latin typeface="Calibri" panose="020F0502020204030204" pitchFamily="34" charset="0"/>
+                <a:cs typeface="Arial" panose="020B0604020202020204" pitchFamily="34" charset="0"/>
+              </a:defRPr>
+            </a:lvl3pPr>
+            <a:lvl4pPr marL="1600200" indent="-228600" eaLnBrk="0" hangingPunct="0">
+              <a:defRPr>
+                <a:solidFill>
+                  <a:schemeClr val="tx1"/>
+                </a:solidFill>
+                <a:latin typeface="Calibri" panose="020F0502020204030204" pitchFamily="34" charset="0"/>
+                <a:cs typeface="Arial" panose="020B0604020202020204" pitchFamily="34" charset="0"/>
+              </a:defRPr>
+            </a:lvl4pPr>
+            <a:lvl5pPr marL="2057400" indent="-228600" eaLnBrk="0" hangingPunct="0">
+              <a:defRPr>
+                <a:solidFill>
+                  <a:schemeClr val="tx1"/>
+                </a:solidFill>
+                <a:latin typeface="Calibri" panose="020F0502020204030204" pitchFamily="34" charset="0"/>
+                <a:cs typeface="Arial" panose="020B0604020202020204" pitchFamily="34" charset="0"/>
+              </a:defRPr>
+            </a:lvl5pPr>
+            <a:lvl6pPr marL="2514600" indent="-228600" eaLnBrk="0" fontAlgn="base" hangingPunct="0">
+              <a:spcBef>
+                <a:spcPct val="0"/>
+              </a:spcBef>
+              <a:spcAft>
+                <a:spcPct val="0"/>
+              </a:spcAft>
+              <a:defRPr>
+                <a:solidFill>
+                  <a:schemeClr val="tx1"/>
+                </a:solidFill>
+                <a:latin typeface="Calibri" panose="020F0502020204030204" pitchFamily="34" charset="0"/>
+                <a:cs typeface="Arial" panose="020B0604020202020204" pitchFamily="34" charset="0"/>
+              </a:defRPr>
+            </a:lvl6pPr>
+            <a:lvl7pPr marL="2971800" indent="-228600" eaLnBrk="0" fontAlgn="base" hangingPunct="0">
+              <a:spcBef>
+                <a:spcPct val="0"/>
+              </a:spcBef>
+              <a:spcAft>
+                <a:spcPct val="0"/>
+              </a:spcAft>
+              <a:defRPr>
+                <a:solidFill>
+                  <a:schemeClr val="tx1"/>
+                </a:solidFill>
+                <a:latin typeface="Calibri" panose="020F0502020204030204" pitchFamily="34" charset="0"/>
+                <a:cs typeface="Arial" panose="020B0604020202020204" pitchFamily="34" charset="0"/>
+              </a:defRPr>
+            </a:lvl7pPr>
+            <a:lvl8pPr marL="3429000" indent="-228600" eaLnBrk="0" fontAlgn="base" hangingPunct="0">
+              <a:spcBef>
+                <a:spcPct val="0"/>
+              </a:spcBef>
+              <a:spcAft>
+                <a:spcPct val="0"/>
+              </a:spcAft>
+              <a:defRPr>
+                <a:solidFill>
+                  <a:schemeClr val="tx1"/>
+                </a:solidFill>
+                <a:latin typeface="Calibri" panose="020F0502020204030204" pitchFamily="34" charset="0"/>
+                <a:cs typeface="Arial" panose="020B0604020202020204" pitchFamily="34" charset="0"/>
+              </a:defRPr>
+            </a:lvl8pPr>
+            <a:lvl9pPr marL="3886200" indent="-228600" eaLnBrk="0" fontAlgn="base" hangingPunct="0">
+              <a:spcBef>
+                <a:spcPct val="0"/>
+              </a:spcBef>
+              <a:spcAft>
+                <a:spcPct val="0"/>
+              </a:spcAft>
+              <a:defRPr>
+                <a:solidFill>
+                  <a:schemeClr val="tx1"/>
+                </a:solidFill>
+                <a:latin typeface="Calibri" panose="020F0502020204030204" pitchFamily="34" charset="0"/>
+                <a:cs typeface="Arial" panose="020B0604020202020204" pitchFamily="34" charset="0"/>
+              </a:defRPr>
+            </a:lvl9pPr>
+          </a:lstStyle>
+          <a:p>
+            <a:pPr marL="0" marR="0" lvl="0" indent="0" algn="l" defTabSz="914400" rtl="0" eaLnBrk="1" fontAlgn="auto" latinLnBrk="0" hangingPunct="1">
+              <a:lnSpc>
+                <a:spcPct val="100000"/>
+              </a:lnSpc>
+              <a:spcBef>
+                <a:spcPts val="0"/>
+              </a:spcBef>
+              <a:spcAft>
+                <a:spcPts val="0"/>
+              </a:spcAft>
+              <a:buClrTx/>
+              <a:buSzTx/>
+              <a:buFontTx/>
+              <a:buNone/>
+              <a:tabLst/>
+              <a:defRPr/>
+            </a:pPr>
+            <a:r>
+              <a:rPr kumimoji="0" lang="en-US" altLang="en-US" sz="1800" b="0" i="0" u="none" strike="noStrike" kern="1200" cap="none" spc="0" normalizeH="0" baseline="0" noProof="0" dirty="0">
+                <a:ln>
+                  <a:noFill/>
+                </a:ln>
+                <a:solidFill>
+                  <a:srgbClr val="898989"/>
+                </a:solidFill>
+                <a:effectLst/>
+                <a:uLnTx/>
+                <a:uFillTx/>
+                <a:latin typeface="Calibri" panose="020F0502020204030204" pitchFamily="34" charset="0"/>
+                <a:ea typeface="+mn-ea"/>
+                <a:cs typeface="Arial" panose="020B0604020202020204" pitchFamily="34" charset="0"/>
+              </a:rPr>
+              <a:t> </a:t>
+            </a:r>
+          </a:p>
+        </p:txBody>
+      </p:sp>
+    </p:spTree>
+    <p:extLst>
+      <p:ext uri="{BB962C8B-B14F-4D97-AF65-F5344CB8AC3E}">
+        <p14:creationId xmlns:p14="http://schemas.microsoft.com/office/powerpoint/2010/main" val="733848517"/>
+      </p:ext>
+    </p:extLst>
+  </p:cSld>
+  <p:clrMapOvr>
+    <a:masterClrMapping/>
+  </p:clrMapOvr>
+</p:sld>
+</file>
+
+<file path=ppt/slides/slide60.xml><?xml version="1.0" encoding="utf-8"?>
 <p:sld xmlns:a="http://schemas.openxmlformats.org/drawingml/2006/main" xmlns:r="http://schemas.openxmlformats.org/officeDocument/2006/relationships" xmlns:p="http://schemas.openxmlformats.org/presentationml/2006/main">
   <p:cSld>
     <p:spTree>
@@ -25175,7 +25595,7 @@
                 <a:tabLst/>
                 <a:defRPr/>
               </a:pPr>
-              <a:t>59</a:t>
+              <a:t>60</a:t>
             </a:fld>
             <a:endParaRPr kumimoji="0" lang="en-US" sz="1800" b="0" i="0" u="none" strike="noStrike" kern="1200" cap="none" spc="0" normalizeH="0" baseline="0" noProof="0" dirty="0">
               <a:ln>
@@ -25325,363 +25745,7 @@
 </p:sld>
 </file>
 
-<file path=ppt/slides/slide6.xml><?xml version="1.0" encoding="utf-8"?>
-<p:sld xmlns:a="http://schemas.openxmlformats.org/drawingml/2006/main" xmlns:r="http://schemas.openxmlformats.org/officeDocument/2006/relationships" xmlns:p="http://schemas.openxmlformats.org/presentationml/2006/main">
-  <p:cSld>
-    <p:spTree>
-      <p:nvGrpSpPr>
-        <p:cNvPr id="1" name=""/>
-        <p:cNvGrpSpPr/>
-        <p:nvPr/>
-      </p:nvGrpSpPr>
-      <p:grpSpPr>
-        <a:xfrm>
-          <a:off x="0" y="0"/>
-          <a:ext cx="0" cy="0"/>
-          <a:chOff x="0" y="0"/>
-          <a:chExt cx="0" cy="0"/>
-        </a:xfrm>
-      </p:grpSpPr>
-      <p:sp>
-        <p:nvSpPr>
-          <p:cNvPr id="4098" name="Title 1"/>
-          <p:cNvSpPr>
-            <a:spLocks noGrp="1"/>
-          </p:cNvSpPr>
-          <p:nvPr>
-            <p:ph type="title"/>
-          </p:nvPr>
-        </p:nvSpPr>
-        <p:spPr>
-          <a:xfrm>
-            <a:off x="936516" y="1170297"/>
-            <a:ext cx="10417284" cy="593767"/>
-          </a:xfrm>
-          <a:ln>
-            <a:miter lim="800000"/>
-            <a:headEnd/>
-            <a:tailEnd/>
-          </a:ln>
-        </p:spPr>
-        <p:txBody>
-          <a:bodyPr/>
-          <a:lstStyle/>
-          <a:p>
-            <a:pPr eaLnBrk="1" hangingPunct="1"/>
-            <a:r>
-              <a:rPr lang="en-US" altLang="en-US" dirty="0"/>
-              <a:t>Graphical User Interfaces (GUI) with Swing</a:t>
-            </a:r>
-          </a:p>
-        </p:txBody>
-      </p:sp>
-      <p:sp>
-        <p:nvSpPr>
-          <p:cNvPr id="4099" name="Content Placeholder 2"/>
-          <p:cNvSpPr>
-            <a:spLocks noGrp="1"/>
-          </p:cNvSpPr>
-          <p:nvPr>
-            <p:ph idx="1"/>
-          </p:nvPr>
-        </p:nvSpPr>
-        <p:spPr>
-          <a:xfrm>
-            <a:off x="936516" y="2190440"/>
-            <a:ext cx="10417284" cy="3835800"/>
-          </a:xfrm>
-          <a:ln>
-            <a:miter lim="800000"/>
-            <a:headEnd/>
-            <a:tailEnd/>
-          </a:ln>
-        </p:spPr>
-        <p:txBody>
-          <a:bodyPr rtlCol="0">
-            <a:normAutofit/>
-          </a:bodyPr>
-          <a:lstStyle/>
-          <a:p>
-            <a:pPr>
-              <a:defRPr/>
-            </a:pPr>
-            <a:r>
-              <a:rPr lang="en-US" sz="2400" dirty="0"/>
-              <a:t>Swing is part of Oracle's Java Foundation Classes (JFC).</a:t>
-            </a:r>
-            <a:endParaRPr lang="en-US" sz="2400" i="1" dirty="0"/>
-          </a:p>
-          <a:p>
-            <a:pPr>
-              <a:defRPr/>
-            </a:pPr>
-            <a:r>
-              <a:rPr lang="en-US" sz="2400" i="1" dirty="0"/>
-              <a:t>You can also use the Standard Widget Toolkit (</a:t>
-            </a:r>
-            <a:r>
-              <a:rPr lang="en-US" sz="2400" i="1" dirty="0">
-                <a:solidFill>
-                  <a:srgbClr val="C00000"/>
-                </a:solidFill>
-              </a:rPr>
-              <a:t>SWT</a:t>
-            </a:r>
-            <a:r>
-              <a:rPr lang="en-US" sz="2400" i="1" dirty="0"/>
-              <a:t>) from Eclipse </a:t>
-            </a:r>
-          </a:p>
-          <a:p>
-            <a:pPr marL="0" indent="0">
-              <a:buNone/>
-              <a:defRPr/>
-            </a:pPr>
-            <a:endParaRPr lang="en-US" sz="2400" dirty="0"/>
-          </a:p>
-          <a:p>
-            <a:pPr marL="0" indent="0">
-              <a:buNone/>
-              <a:defRPr/>
-            </a:pPr>
-            <a:r>
-              <a:rPr lang="en-US" sz="2400" b="1" dirty="0"/>
-              <a:t>Before Swing: </a:t>
-            </a:r>
-            <a:endParaRPr lang="en-US" sz="2400" b="1" dirty="0">
-              <a:solidFill>
-                <a:srgbClr val="C00000"/>
-              </a:solidFill>
-            </a:endParaRPr>
-          </a:p>
-          <a:p>
-            <a:pPr>
-              <a:defRPr/>
-            </a:pPr>
-            <a:endParaRPr lang="en-US" sz="2400" dirty="0">
-              <a:solidFill>
-                <a:srgbClr val="C00000"/>
-              </a:solidFill>
-            </a:endParaRPr>
-          </a:p>
-          <a:p>
-            <a:pPr>
-              <a:defRPr/>
-            </a:pPr>
-            <a:r>
-              <a:rPr lang="en-US" sz="2400" dirty="0">
-                <a:solidFill>
-                  <a:srgbClr val="C00000"/>
-                </a:solidFill>
-              </a:rPr>
-              <a:t>Abstract Window Toolkit (AWT) </a:t>
-            </a:r>
-            <a:r>
-              <a:rPr lang="en-US" sz="2400" dirty="0"/>
-              <a:t>was the original. </a:t>
-            </a:r>
-          </a:p>
-          <a:p>
-            <a:pPr>
-              <a:defRPr/>
-            </a:pPr>
-            <a:endParaRPr lang="en-US" sz="2400" dirty="0"/>
-          </a:p>
-          <a:p>
-            <a:pPr>
-              <a:defRPr/>
-            </a:pPr>
-            <a:r>
-              <a:rPr lang="en-US" sz="2400" dirty="0"/>
-              <a:t>Limited set of GUI components, layout managers, events, etc.</a:t>
-            </a:r>
-          </a:p>
-          <a:p>
-            <a:pPr>
-              <a:defRPr/>
-            </a:pPr>
-            <a:endParaRPr lang="en-US" sz="2400" dirty="0"/>
-          </a:p>
-          <a:p>
-            <a:pPr>
-              <a:defRPr/>
-            </a:pPr>
-            <a:endParaRPr lang="en-US" sz="2000" dirty="0"/>
-          </a:p>
-        </p:txBody>
-      </p:sp>
-      <p:sp>
-        <p:nvSpPr>
-          <p:cNvPr id="4" name="Slide Number Placeholder 3"/>
-          <p:cNvSpPr>
-            <a:spLocks noGrp="1"/>
-          </p:cNvSpPr>
-          <p:nvPr>
-            <p:ph type="sldNum" sz="quarter" idx="10"/>
-          </p:nvPr>
-        </p:nvSpPr>
-        <p:spPr/>
-        <p:txBody>
-          <a:bodyPr/>
-          <a:lstStyle>
-            <a:lvl1pPr eaLnBrk="0" hangingPunct="0">
-              <a:defRPr>
-                <a:solidFill>
-                  <a:schemeClr val="tx1"/>
-                </a:solidFill>
-                <a:latin typeface="Calibri" panose="020F0502020204030204" pitchFamily="34" charset="0"/>
-                <a:cs typeface="Arial" panose="020B0604020202020204" pitchFamily="34" charset="0"/>
-              </a:defRPr>
-            </a:lvl1pPr>
-            <a:lvl2pPr marL="742950" indent="-285750" eaLnBrk="0" hangingPunct="0">
-              <a:defRPr>
-                <a:solidFill>
-                  <a:schemeClr val="tx1"/>
-                </a:solidFill>
-                <a:latin typeface="Calibri" panose="020F0502020204030204" pitchFamily="34" charset="0"/>
-                <a:cs typeface="Arial" panose="020B0604020202020204" pitchFamily="34" charset="0"/>
-              </a:defRPr>
-            </a:lvl2pPr>
-            <a:lvl3pPr marL="1143000" indent="-228600" eaLnBrk="0" hangingPunct="0">
-              <a:defRPr>
-                <a:solidFill>
-                  <a:schemeClr val="tx1"/>
-                </a:solidFill>
-                <a:latin typeface="Calibri" panose="020F0502020204030204" pitchFamily="34" charset="0"/>
-                <a:cs typeface="Arial" panose="020B0604020202020204" pitchFamily="34" charset="0"/>
-              </a:defRPr>
-            </a:lvl3pPr>
-            <a:lvl4pPr marL="1600200" indent="-228600" eaLnBrk="0" hangingPunct="0">
-              <a:defRPr>
-                <a:solidFill>
-                  <a:schemeClr val="tx1"/>
-                </a:solidFill>
-                <a:latin typeface="Calibri" panose="020F0502020204030204" pitchFamily="34" charset="0"/>
-                <a:cs typeface="Arial" panose="020B0604020202020204" pitchFamily="34" charset="0"/>
-              </a:defRPr>
-            </a:lvl4pPr>
-            <a:lvl5pPr marL="2057400" indent="-228600" eaLnBrk="0" hangingPunct="0">
-              <a:defRPr>
-                <a:solidFill>
-                  <a:schemeClr val="tx1"/>
-                </a:solidFill>
-                <a:latin typeface="Calibri" panose="020F0502020204030204" pitchFamily="34" charset="0"/>
-                <a:cs typeface="Arial" panose="020B0604020202020204" pitchFamily="34" charset="0"/>
-              </a:defRPr>
-            </a:lvl5pPr>
-            <a:lvl6pPr marL="2514600" indent="-228600" eaLnBrk="0" fontAlgn="base" hangingPunct="0">
-              <a:spcBef>
-                <a:spcPct val="0"/>
-              </a:spcBef>
-              <a:spcAft>
-                <a:spcPct val="0"/>
-              </a:spcAft>
-              <a:defRPr>
-                <a:solidFill>
-                  <a:schemeClr val="tx1"/>
-                </a:solidFill>
-                <a:latin typeface="Calibri" panose="020F0502020204030204" pitchFamily="34" charset="0"/>
-                <a:cs typeface="Arial" panose="020B0604020202020204" pitchFamily="34" charset="0"/>
-              </a:defRPr>
-            </a:lvl6pPr>
-            <a:lvl7pPr marL="2971800" indent="-228600" eaLnBrk="0" fontAlgn="base" hangingPunct="0">
-              <a:spcBef>
-                <a:spcPct val="0"/>
-              </a:spcBef>
-              <a:spcAft>
-                <a:spcPct val="0"/>
-              </a:spcAft>
-              <a:defRPr>
-                <a:solidFill>
-                  <a:schemeClr val="tx1"/>
-                </a:solidFill>
-                <a:latin typeface="Calibri" panose="020F0502020204030204" pitchFamily="34" charset="0"/>
-                <a:cs typeface="Arial" panose="020B0604020202020204" pitchFamily="34" charset="0"/>
-              </a:defRPr>
-            </a:lvl7pPr>
-            <a:lvl8pPr marL="3429000" indent="-228600" eaLnBrk="0" fontAlgn="base" hangingPunct="0">
-              <a:spcBef>
-                <a:spcPct val="0"/>
-              </a:spcBef>
-              <a:spcAft>
-                <a:spcPct val="0"/>
-              </a:spcAft>
-              <a:defRPr>
-                <a:solidFill>
-                  <a:schemeClr val="tx1"/>
-                </a:solidFill>
-                <a:latin typeface="Calibri" panose="020F0502020204030204" pitchFamily="34" charset="0"/>
-                <a:cs typeface="Arial" panose="020B0604020202020204" pitchFamily="34" charset="0"/>
-              </a:defRPr>
-            </a:lvl8pPr>
-            <a:lvl9pPr marL="3886200" indent="-228600" eaLnBrk="0" fontAlgn="base" hangingPunct="0">
-              <a:spcBef>
-                <a:spcPct val="0"/>
-              </a:spcBef>
-              <a:spcAft>
-                <a:spcPct val="0"/>
-              </a:spcAft>
-              <a:defRPr>
-                <a:solidFill>
-                  <a:schemeClr val="tx1"/>
-                </a:solidFill>
-                <a:latin typeface="Calibri" panose="020F0502020204030204" pitchFamily="34" charset="0"/>
-                <a:cs typeface="Arial" panose="020B0604020202020204" pitchFamily="34" charset="0"/>
-              </a:defRPr>
-            </a:lvl9pPr>
-          </a:lstStyle>
-          <a:p>
-            <a:pPr marL="0" marR="0" lvl="0" indent="0" algn="l" defTabSz="914400" rtl="0" eaLnBrk="1" fontAlgn="auto" latinLnBrk="0" hangingPunct="1">
-              <a:lnSpc>
-                <a:spcPct val="100000"/>
-              </a:lnSpc>
-              <a:spcBef>
-                <a:spcPts val="0"/>
-              </a:spcBef>
-              <a:spcAft>
-                <a:spcPts val="0"/>
-              </a:spcAft>
-              <a:buClrTx/>
-              <a:buSzTx/>
-              <a:buFontTx/>
-              <a:buNone/>
-              <a:tabLst/>
-              <a:defRPr/>
-            </a:pPr>
-            <a:r>
-              <a:rPr kumimoji="0" lang="en-US" altLang="en-US" sz="1800" b="0" i="0" u="none" strike="noStrike" kern="1200" cap="none" spc="0" normalizeH="0" baseline="0" noProof="0" dirty="0">
-                <a:ln>
-                  <a:noFill/>
-                </a:ln>
-                <a:solidFill>
-                  <a:srgbClr val="898989"/>
-                </a:solidFill>
-                <a:effectLst/>
-                <a:uLnTx/>
-                <a:uFillTx/>
-                <a:latin typeface="Calibri" panose="020F0502020204030204" pitchFamily="34" charset="0"/>
-                <a:ea typeface="+mn-ea"/>
-                <a:cs typeface="Arial" panose="020B0604020202020204" pitchFamily="34" charset="0"/>
-              </a:rPr>
-              <a:t> </a:t>
-            </a:r>
-          </a:p>
-        </p:txBody>
-      </p:sp>
-    </p:spTree>
-    <p:extLst>
-      <p:ext uri="{BB962C8B-B14F-4D97-AF65-F5344CB8AC3E}">
-        <p14:creationId xmlns:p14="http://schemas.microsoft.com/office/powerpoint/2010/main" val="733848517"/>
-      </p:ext>
-    </p:extLst>
-  </p:cSld>
-  <p:clrMapOvr>
-    <a:masterClrMapping/>
-  </p:clrMapOvr>
-</p:sld>
-</file>
-
-<file path=ppt/slides/slide60.xml><?xml version="1.0" encoding="utf-8"?>
+<file path=ppt/slides/slide61.xml><?xml version="1.0" encoding="utf-8"?>
 <p:sld xmlns:a="http://schemas.openxmlformats.org/drawingml/2006/main" xmlns:r="http://schemas.openxmlformats.org/officeDocument/2006/relationships" xmlns:p="http://schemas.openxmlformats.org/presentationml/2006/main">
   <p:cSld>
     <p:spTree>
@@ -25843,7 +25907,7 @@
                 <a:tabLst/>
                 <a:defRPr/>
               </a:pPr>
-              <a:t>60</a:t>
+              <a:t>61</a:t>
             </a:fld>
             <a:endParaRPr kumimoji="0" lang="en-US" sz="1800" b="0" i="0" u="none" strike="noStrike" kern="1200" cap="none" spc="0" normalizeH="0" baseline="0" noProof="0" dirty="0">
               <a:ln>
@@ -25923,7 +25987,7 @@
 </p:sld>
 </file>
 
-<file path=ppt/slides/slide61.xml><?xml version="1.0" encoding="utf-8"?>
+<file path=ppt/slides/slide62.xml><?xml version="1.0" encoding="utf-8"?>
 <p:sld xmlns:a="http://schemas.openxmlformats.org/drawingml/2006/main" xmlns:r="http://schemas.openxmlformats.org/officeDocument/2006/relationships" xmlns:p="http://schemas.openxmlformats.org/presentationml/2006/main">
   <p:cSld>
     <p:spTree>
@@ -26182,7 +26246,7 @@
                 <a:tabLst/>
                 <a:defRPr/>
               </a:pPr>
-              <a:t>61</a:t>
+              <a:t>62</a:t>
             </a:fld>
             <a:endParaRPr kumimoji="0" lang="en-US" altLang="en-US" sz="1200" b="0" i="0" u="none" strike="noStrike" kern="1200" cap="none" spc="0" normalizeH="0" baseline="0" noProof="0">
               <a:ln>
@@ -26214,7 +26278,7 @@
 </p:sld>
 </file>
 
-<file path=ppt/slides/slide62.xml><?xml version="1.0" encoding="utf-8"?>
+<file path=ppt/slides/slide63.xml><?xml version="1.0" encoding="utf-8"?>
 <p:sld xmlns:a="http://schemas.openxmlformats.org/drawingml/2006/main" xmlns:r="http://schemas.openxmlformats.org/officeDocument/2006/relationships" xmlns:p="http://schemas.openxmlformats.org/presentationml/2006/main">
   <p:cSld>
     <p:spTree>
@@ -26376,7 +26440,7 @@
                 <a:tabLst/>
                 <a:defRPr/>
               </a:pPr>
-              <a:t>62</a:t>
+              <a:t>63</a:t>
             </a:fld>
             <a:endParaRPr kumimoji="0" lang="en-US" sz="1800" b="0" i="0" u="none" strike="noStrike" kern="1200" cap="none" spc="0" normalizeH="0" baseline="0" noProof="0" dirty="0">
               <a:ln>
@@ -26805,7 +26869,7 @@
 </p:sld>
 </file>
 
-<file path=ppt/slides/slide63.xml><?xml version="1.0" encoding="utf-8"?>
+<file path=ppt/slides/slide64.xml><?xml version="1.0" encoding="utf-8"?>
 <p:sld xmlns:a="http://schemas.openxmlformats.org/drawingml/2006/main" xmlns:r="http://schemas.openxmlformats.org/officeDocument/2006/relationships" xmlns:p="http://schemas.openxmlformats.org/presentationml/2006/main">
   <p:cSld>
     <p:spTree>
@@ -26967,7 +27031,7 @@
                 <a:tabLst/>
                 <a:defRPr/>
               </a:pPr>
-              <a:t>63</a:t>
+              <a:t>64</a:t>
             </a:fld>
             <a:endParaRPr kumimoji="0" lang="en-US" sz="1800" b="0" i="0" u="none" strike="noStrike" kern="1200" cap="none" spc="0" normalizeH="0" baseline="0" noProof="0" dirty="0">
               <a:ln>
@@ -27335,7 +27399,7 @@
 </p:sld>
 </file>
 
-<file path=ppt/slides/slide64.xml><?xml version="1.0" encoding="utf-8"?>
+<file path=ppt/slides/slide65.xml><?xml version="1.0" encoding="utf-8"?>
 <p:sld xmlns:a="http://schemas.openxmlformats.org/drawingml/2006/main" xmlns:r="http://schemas.openxmlformats.org/officeDocument/2006/relationships" xmlns:p="http://schemas.openxmlformats.org/presentationml/2006/main">
   <p:cSld>
     <p:spTree>
@@ -27497,7 +27561,7 @@
                 <a:tabLst/>
                 <a:defRPr/>
               </a:pPr>
-              <a:t>64</a:t>
+              <a:t>65</a:t>
             </a:fld>
             <a:endParaRPr kumimoji="0" lang="en-US" sz="1800" b="0" i="0" u="none" strike="noStrike" kern="1200" cap="none" spc="0" normalizeH="0" baseline="0" noProof="0" dirty="0">
               <a:ln>
@@ -27577,7 +27641,7 @@
 </p:sld>
 </file>
 
-<file path=ppt/slides/slide65.xml><?xml version="1.0" encoding="utf-8"?>
+<file path=ppt/slides/slide66.xml><?xml version="1.0" encoding="utf-8"?>
 <p:sld xmlns:a="http://schemas.openxmlformats.org/drawingml/2006/main" xmlns:r="http://schemas.openxmlformats.org/officeDocument/2006/relationships" xmlns:p="http://schemas.openxmlformats.org/presentationml/2006/main">
   <p:cSld>
     <p:spTree>
@@ -27814,70 +27878,6 @@
     <p:extLst>
       <p:ext uri="{BB962C8B-B14F-4D97-AF65-F5344CB8AC3E}">
         <p14:creationId xmlns:p14="http://schemas.microsoft.com/office/powerpoint/2010/main" val="361343503"/>
-      </p:ext>
-    </p:extLst>
-  </p:cSld>
-  <p:clrMapOvr>
-    <a:masterClrMapping/>
-  </p:clrMapOvr>
-</p:sld>
-</file>
-
-<file path=ppt/slides/slide66.xml><?xml version="1.0" encoding="utf-8"?>
-<p:sld xmlns:a="http://schemas.openxmlformats.org/drawingml/2006/main" xmlns:r="http://schemas.openxmlformats.org/officeDocument/2006/relationships" xmlns:p="http://schemas.openxmlformats.org/presentationml/2006/main">
-  <p:cSld>
-    <p:spTree>
-      <p:nvGrpSpPr>
-        <p:cNvPr id="1" name="">
-          <a:extLst>
-            <a:ext uri="{FF2B5EF4-FFF2-40B4-BE49-F238E27FC236}">
-              <a16:creationId xmlns:a16="http://schemas.microsoft.com/office/drawing/2014/main" id="{84DA25F2-3AE0-BDCF-0880-EDD5EEF55E54}"/>
-            </a:ext>
-          </a:extLst>
-        </p:cNvPr>
-        <p:cNvGrpSpPr/>
-        <p:nvPr/>
-      </p:nvGrpSpPr>
-      <p:grpSpPr>
-        <a:xfrm>
-          <a:off x="0" y="0"/>
-          <a:ext cx="0" cy="0"/>
-          <a:chOff x="0" y="0"/>
-          <a:chExt cx="0" cy="0"/>
-        </a:xfrm>
-      </p:grpSpPr>
-      <p:sp>
-        <p:nvSpPr>
-          <p:cNvPr id="2" name="Title 1">
-            <a:extLst>
-              <a:ext uri="{FF2B5EF4-FFF2-40B4-BE49-F238E27FC236}">
-                <a16:creationId xmlns:a16="http://schemas.microsoft.com/office/drawing/2014/main" id="{6EAE57A2-3A61-C5F8-EEFD-EA2961784338}"/>
-              </a:ext>
-            </a:extLst>
-          </p:cNvPr>
-          <p:cNvSpPr>
-            <a:spLocks noGrp="1"/>
-          </p:cNvSpPr>
-          <p:nvPr>
-            <p:ph type="ctrTitle"/>
-          </p:nvPr>
-        </p:nvSpPr>
-        <p:spPr/>
-        <p:txBody>
-          <a:bodyPr/>
-          <a:lstStyle/>
-          <a:p>
-            <a:r>
-              <a:rPr lang="en-US" dirty="0"/>
-              <a:t>… to here …</a:t>
-            </a:r>
-          </a:p>
-        </p:txBody>
-      </p:sp>
-    </p:spTree>
-    <p:extLst>
-      <p:ext uri="{BB962C8B-B14F-4D97-AF65-F5344CB8AC3E}">
-        <p14:creationId xmlns:p14="http://schemas.microsoft.com/office/powerpoint/2010/main" val="2815624037"/>
       </p:ext>
     </p:extLst>
   </p:cSld>

</xml_diff>